<commit_message>
docs: add Cogniro requirements walkthrough deck
Companion presentation that goes through the functional requirements
WF01-WF21 one by one. Each slide shows the requirement code and a
single screenshot proving where that requirement is satisfied in the
running application: question types, multimedia, time limits, random
order, QR-code join, scoring, answer review, ranking with 30-day
retention, AGH branding, nickname blocking, slider question type,
question preview, ZIP export/import, in-app tutorials, and post-quiz
WI AGH link. Closes with coverage summary and two project-estimate
slides (scope, effort, market pricing scenarios, most-likely band).

Co-Authored-By: Claude Opus 4.7 <noreply@anthropic.com>
</commit_message>
<xml_diff>
--- a/docs/cogniro-requirements.pptx
+++ b/docs/cogniro-requirements.pptx
@@ -24,6 +24,8 @@
     <p:sldId id="272" r:id="rId23"/>
     <p:sldId id="273" r:id="rId24"/>
     <p:sldId id="274" r:id="rId25"/>
+    <p:sldId id="275" r:id="rId26"/>
+    <p:sldId id="276" r:id="rId27"/>
   </p:sldIdLst>
   <p:sldSz cx="12192119" cy="6858000" type="screen4x3"/>
   <p:notesSz cx="6858000" cy="9144000"/>
@@ -3223,7 +3225,7 @@
                 </a:solidFill>
                 <a:latin typeface="Calibri"/>
               </a:rPr>
-              <a:t>Realizacja wymagań</a:t>
+              <a:t>Pokrycie wymagań funkcjonalnych — przegląd po WF01–WF21</a:t>
             </a:r>
           </a:p>
         </p:txBody>
@@ -3556,7 +3558,7 @@
                 </a:solidFill>
                 <a:latin typeface="Calibri"/>
               </a:rPr>
-              <a:t>10 / 19</a:t>
+              <a:t>10 / 21</a:t>
             </a:r>
           </a:p>
         </p:txBody>
@@ -3922,7 +3924,7 @@
                 </a:solidFill>
                 <a:latin typeface="Calibri"/>
               </a:rPr>
-              <a:t>11 / 19</a:t>
+              <a:t>11 / 21</a:t>
             </a:r>
           </a:p>
         </p:txBody>
@@ -4288,7 +4290,7 @@
                 </a:solidFill>
                 <a:latin typeface="Calibri"/>
               </a:rPr>
-              <a:t>12 / 19</a:t>
+              <a:t>12 / 21</a:t>
             </a:r>
           </a:p>
         </p:txBody>
@@ -4654,7 +4656,7 @@
                 </a:solidFill>
                 <a:latin typeface="Calibri"/>
               </a:rPr>
-              <a:t>13 / 19</a:t>
+              <a:t>13 / 21</a:t>
             </a:r>
           </a:p>
         </p:txBody>
@@ -5020,7 +5022,7 @@
                 </a:solidFill>
                 <a:latin typeface="Calibri"/>
               </a:rPr>
-              <a:t>14 / 19</a:t>
+              <a:t>14 / 21</a:t>
             </a:r>
           </a:p>
         </p:txBody>
@@ -5386,7 +5388,7 @@
                 </a:solidFill>
                 <a:latin typeface="Calibri"/>
               </a:rPr>
-              <a:t>15 / 19</a:t>
+              <a:t>15 / 21</a:t>
             </a:r>
           </a:p>
         </p:txBody>
@@ -5752,7 +5754,7 @@
                 </a:solidFill>
                 <a:latin typeface="Calibri"/>
               </a:rPr>
-              <a:t>16 / 19</a:t>
+              <a:t>16 / 21</a:t>
             </a:r>
           </a:p>
         </p:txBody>
@@ -6118,7 +6120,7 @@
                 </a:solidFill>
                 <a:latin typeface="Calibri"/>
               </a:rPr>
-              <a:t>17 / 19</a:t>
+              <a:t>17 / 21</a:t>
             </a:r>
           </a:p>
         </p:txBody>
@@ -6484,7 +6486,7 @@
                 </a:solidFill>
                 <a:latin typeface="Calibri"/>
               </a:rPr>
-              <a:t>18 / 19</a:t>
+              <a:t>18 / 21</a:t>
             </a:r>
           </a:p>
         </p:txBody>
@@ -6771,7 +6773,7 @@
                 </a:solidFill>
                 <a:latin typeface="Calibri"/>
               </a:rPr>
-              <a:t>19 / 19</a:t>
+              <a:t>19 / 21</a:t>
             </a:r>
           </a:p>
         </p:txBody>
@@ -7432,7 +7434,7 @@
                 </a:solidFill>
                 <a:latin typeface="Calibri"/>
               </a:rPr>
-              <a:t>2 / 19</a:t>
+              <a:t>2 / 21</a:t>
             </a:r>
           </a:p>
         </p:txBody>
@@ -7536,6 +7538,2284 @@
                 <a:latin typeface="Calibri"/>
               </a:rPr>
               <a:t>W edytorze administrator wpisuje treść pytania, dodaje listę odpowiedzi i zaznacza tę poprawną (radio button po lewej każdej opcji).</a:t>
+            </a:r>
+          </a:p>
+        </p:txBody>
+      </p:sp>
+    </p:spTree>
+  </p:cSld>
+  <p:clrMapOvr>
+    <a:masterClrMapping/>
+  </p:clrMapOvr>
+</p:sld>
+</file>
+
+<file path=ppt/slides/slide20.xml><?xml version="1.0" encoding="utf-8"?>
+<p:sld xmlns:a="http://schemas.openxmlformats.org/drawingml/2006/main" xmlns:p="http://schemas.openxmlformats.org/presentationml/2006/main" xmlns:r="http://schemas.openxmlformats.org/officeDocument/2006/relationships">
+  <p:cSld>
+    <p:bg>
+      <p:bgPr>
+        <a:solidFill>
+          <a:srgbClr val="FFFFFF"/>
+        </a:solidFill>
+        <a:effectLst/>
+      </p:bgPr>
+    </p:bg>
+    <p:spTree>
+      <p:nvGrpSpPr>
+        <p:cNvPr id="1" name=""/>
+        <p:cNvGrpSpPr/>
+        <p:nvPr/>
+      </p:nvGrpSpPr>
+      <p:grpSpPr/>
+      <p:sp>
+        <p:nvSpPr>
+          <p:cNvPr id="2" name="Rectangle 1"/>
+          <p:cNvSpPr/>
+          <p:nvPr/>
+        </p:nvSpPr>
+        <p:spPr>
+          <a:xfrm>
+            <a:off x="0" y="0"/>
+            <a:ext cx="12192119" cy="720000"/>
+          </a:xfrm>
+          <a:prstGeom prst="rect">
+            <a:avLst/>
+          </a:prstGeom>
+          <a:solidFill>
+            <a:srgbClr val="1F4E79"/>
+          </a:solidFill>
+          <a:ln>
+            <a:noFill/>
+          </a:ln>
+          <a:effectLst/>
+        </p:spPr>
+        <p:style>
+          <a:lnRef idx="1">
+            <a:schemeClr val="accent1"/>
+          </a:lnRef>
+          <a:fillRef idx="3">
+            <a:schemeClr val="accent1"/>
+          </a:fillRef>
+          <a:effectRef idx="2">
+            <a:schemeClr val="accent1"/>
+          </a:effectRef>
+          <a:fontRef idx="minor">
+            <a:schemeClr val="lt1"/>
+          </a:fontRef>
+        </p:style>
+        <p:txBody>
+          <a:bodyPr rtlCol="0" anchor="ctr"/>
+          <a:lstStyle/>
+          <a:p>
+            <a:pPr algn="ctr"/>
+          </a:p>
+        </p:txBody>
+      </p:sp>
+      <p:sp>
+        <p:nvSpPr>
+          <p:cNvPr id="3" name="Rectangle 2"/>
+          <p:cNvSpPr/>
+          <p:nvPr/>
+        </p:nvSpPr>
+        <p:spPr>
+          <a:xfrm>
+            <a:off x="0" y="720000"/>
+            <a:ext cx="12192119" cy="36000"/>
+          </a:xfrm>
+          <a:prstGeom prst="rect">
+            <a:avLst/>
+          </a:prstGeom>
+          <a:solidFill>
+            <a:srgbClr val="E8B44F"/>
+          </a:solidFill>
+          <a:ln>
+            <a:noFill/>
+          </a:ln>
+          <a:effectLst/>
+        </p:spPr>
+        <p:style>
+          <a:lnRef idx="1">
+            <a:schemeClr val="accent1"/>
+          </a:lnRef>
+          <a:fillRef idx="3">
+            <a:schemeClr val="accent1"/>
+          </a:fillRef>
+          <a:effectRef idx="2">
+            <a:schemeClr val="accent1"/>
+          </a:effectRef>
+          <a:fontRef idx="minor">
+            <a:schemeClr val="lt1"/>
+          </a:fontRef>
+        </p:style>
+        <p:txBody>
+          <a:bodyPr rtlCol="0" anchor="ctr"/>
+          <a:lstStyle/>
+          <a:p>
+            <a:pPr algn="ctr"/>
+          </a:p>
+        </p:txBody>
+      </p:sp>
+      <p:sp>
+        <p:nvSpPr>
+          <p:cNvPr id="4" name="TextBox 3"/>
+          <p:cNvSpPr txBox="1"/>
+          <p:nvPr/>
+        </p:nvSpPr>
+        <p:spPr>
+          <a:xfrm>
+            <a:off x="360000" y="198000"/>
+            <a:ext cx="11472119" cy="432000"/>
+          </a:xfrm>
+          <a:prstGeom prst="rect">
+            <a:avLst/>
+          </a:prstGeom>
+          <a:noFill/>
+        </p:spPr>
+        <p:txBody>
+          <a:bodyPr wrap="square" lIns="0" rIns="0" tIns="0" bIns="0">
+            <a:spAutoFit/>
+          </a:bodyPr>
+          <a:lstStyle/>
+          <a:p>
+            <a:pPr algn="l"/>
+            <a:r>
+              <a:rPr sz="2400" b="1" i="0">
+                <a:solidFill>
+                  <a:srgbClr val="FFFFFF"/>
+                </a:solidFill>
+                <a:latin typeface="Calibri"/>
+              </a:rPr>
+              <a:t>Wycena projektu — zakres i nakład pracy</a:t>
+            </a:r>
+          </a:p>
+        </p:txBody>
+      </p:sp>
+      <p:sp>
+        <p:nvSpPr>
+          <p:cNvPr id="5" name="TextBox 4"/>
+          <p:cNvSpPr txBox="1"/>
+          <p:nvPr/>
+        </p:nvSpPr>
+        <p:spPr>
+          <a:xfrm>
+            <a:off x="11112119" y="270000"/>
+            <a:ext cx="900000" cy="216000"/>
+          </a:xfrm>
+          <a:prstGeom prst="rect">
+            <a:avLst/>
+          </a:prstGeom>
+          <a:noFill/>
+        </p:spPr>
+        <p:txBody>
+          <a:bodyPr wrap="square" lIns="0" rIns="0" tIns="0" bIns="0">
+            <a:spAutoFit/>
+          </a:bodyPr>
+          <a:lstStyle/>
+          <a:p>
+            <a:pPr algn="r"/>
+            <a:r>
+              <a:rPr sz="1000" b="0" i="0">
+                <a:solidFill>
+                  <a:srgbClr val="E8F0F9"/>
+                </a:solidFill>
+                <a:latin typeface="Calibri"/>
+              </a:rPr>
+              <a:t>20 / 21</a:t>
+            </a:r>
+          </a:p>
+        </p:txBody>
+      </p:sp>
+      <p:sp>
+        <p:nvSpPr>
+          <p:cNvPr id="6" name="TextBox 5"/>
+          <p:cNvSpPr txBox="1"/>
+          <p:nvPr/>
+        </p:nvSpPr>
+        <p:spPr>
+          <a:xfrm>
+            <a:off x="540000" y="1007999"/>
+            <a:ext cx="11112119" cy="720000"/>
+          </a:xfrm>
+          <a:prstGeom prst="rect">
+            <a:avLst/>
+          </a:prstGeom>
+          <a:noFill/>
+        </p:spPr>
+        <p:txBody>
+          <a:bodyPr wrap="square" lIns="0" rIns="0" tIns="0" bIns="0">
+            <a:spAutoFit/>
+          </a:bodyPr>
+          <a:lstStyle/>
+          <a:p>
+            <a:pPr algn="l"/>
+            <a:r>
+              <a:rPr sz="1300" b="0" i="1">
+                <a:solidFill>
+                  <a:srgbClr val="1A1A1A"/>
+                </a:solidFill>
+                <a:latin typeface="Calibri"/>
+              </a:rPr>
+              <a:t>Wycena oparta na faktycznym, zinwentaryzowanym zakresie repozytorium. Platforma do quizów na żywo z panelem administratora, edytorem quizów, trybem prezentera, sesjami na PIN, leaderboardem na żywo, archiwum wyników oraz importem i eksportem.</a:t>
+            </a:r>
+          </a:p>
+        </p:txBody>
+      </p:sp>
+      <p:sp>
+        <p:nvSpPr>
+          <p:cNvPr id="7" name="TextBox 6"/>
+          <p:cNvSpPr txBox="1"/>
+          <p:nvPr/>
+        </p:nvSpPr>
+        <p:spPr>
+          <a:xfrm>
+            <a:off x="540000" y="1980000"/>
+            <a:ext cx="5400000" cy="288000"/>
+          </a:xfrm>
+          <a:prstGeom prst="rect">
+            <a:avLst/>
+          </a:prstGeom>
+          <a:noFill/>
+        </p:spPr>
+        <p:txBody>
+          <a:bodyPr wrap="square" lIns="0" rIns="0" tIns="0" bIns="0">
+            <a:spAutoFit/>
+          </a:bodyPr>
+          <a:lstStyle/>
+          <a:p>
+            <a:pPr algn="l"/>
+            <a:r>
+              <a:rPr sz="1500" b="1" i="0">
+                <a:solidFill>
+                  <a:srgbClr val="1F4E79"/>
+                </a:solidFill>
+                <a:latin typeface="Calibri"/>
+              </a:rPr>
+              <a:t>Zmierzony rozmiar</a:t>
+            </a:r>
+          </a:p>
+        </p:txBody>
+      </p:sp>
+      <p:sp>
+        <p:nvSpPr>
+          <p:cNvPr id="8" name="TextBox 7"/>
+          <p:cNvSpPr txBox="1"/>
+          <p:nvPr/>
+        </p:nvSpPr>
+        <p:spPr>
+          <a:xfrm>
+            <a:off x="540000" y="2304000"/>
+            <a:ext cx="2700000" cy="251999"/>
+          </a:xfrm>
+          <a:prstGeom prst="rect">
+            <a:avLst/>
+          </a:prstGeom>
+          <a:noFill/>
+        </p:spPr>
+        <p:txBody>
+          <a:bodyPr wrap="square" lIns="0" rIns="0" tIns="0" bIns="0">
+            <a:spAutoFit/>
+          </a:bodyPr>
+          <a:lstStyle/>
+          <a:p>
+            <a:pPr algn="l"/>
+            <a:r>
+              <a:rPr sz="1100" b="1" i="0">
+                <a:solidFill>
+                  <a:srgbClr val="1A1A1A"/>
+                </a:solidFill>
+                <a:latin typeface="Calibri"/>
+              </a:rPr>
+              <a:t>Backend (FastAPI, Python)</a:t>
+            </a:r>
+          </a:p>
+        </p:txBody>
+      </p:sp>
+      <p:sp>
+        <p:nvSpPr>
+          <p:cNvPr id="9" name="TextBox 8"/>
+          <p:cNvSpPr txBox="1"/>
+          <p:nvPr/>
+        </p:nvSpPr>
+        <p:spPr>
+          <a:xfrm>
+            <a:off x="3311999" y="2304000"/>
+            <a:ext cx="3168000" cy="251999"/>
+          </a:xfrm>
+          <a:prstGeom prst="rect">
+            <a:avLst/>
+          </a:prstGeom>
+          <a:noFill/>
+        </p:spPr>
+        <p:txBody>
+          <a:bodyPr wrap="square" lIns="0" rIns="0" tIns="0" bIns="0">
+            <a:spAutoFit/>
+          </a:bodyPr>
+          <a:lstStyle/>
+          <a:p>
+            <a:pPr algn="l"/>
+            <a:r>
+              <a:rPr sz="1100" b="0" i="0">
+                <a:solidFill>
+                  <a:srgbClr val="1A1A1A"/>
+                </a:solidFill>
+                <a:latin typeface="Calibri"/>
+              </a:rPr>
+              <a:t>~9 300 linii kodu, 60 plików</a:t>
+            </a:r>
+          </a:p>
+        </p:txBody>
+      </p:sp>
+      <p:sp>
+        <p:nvSpPr>
+          <p:cNvPr id="10" name="TextBox 9"/>
+          <p:cNvSpPr txBox="1"/>
+          <p:nvPr/>
+        </p:nvSpPr>
+        <p:spPr>
+          <a:xfrm>
+            <a:off x="540000" y="2555999"/>
+            <a:ext cx="2700000" cy="251999"/>
+          </a:xfrm>
+          <a:prstGeom prst="rect">
+            <a:avLst/>
+          </a:prstGeom>
+          <a:noFill/>
+        </p:spPr>
+        <p:txBody>
+          <a:bodyPr wrap="square" lIns="0" rIns="0" tIns="0" bIns="0">
+            <a:spAutoFit/>
+          </a:bodyPr>
+          <a:lstStyle/>
+          <a:p>
+            <a:pPr algn="l"/>
+            <a:r>
+              <a:rPr sz="1100" b="1" i="0">
+                <a:solidFill>
+                  <a:srgbClr val="1A1A1A"/>
+                </a:solidFill>
+                <a:latin typeface="Calibri"/>
+              </a:rPr>
+              <a:t>Frontend (Next.js)</a:t>
+            </a:r>
+          </a:p>
+        </p:txBody>
+      </p:sp>
+      <p:sp>
+        <p:nvSpPr>
+          <p:cNvPr id="11" name="TextBox 10"/>
+          <p:cNvSpPr txBox="1"/>
+          <p:nvPr/>
+        </p:nvSpPr>
+        <p:spPr>
+          <a:xfrm>
+            <a:off x="3311999" y="2555999"/>
+            <a:ext cx="3168000" cy="251999"/>
+          </a:xfrm>
+          <a:prstGeom prst="rect">
+            <a:avLst/>
+          </a:prstGeom>
+          <a:noFill/>
+        </p:spPr>
+        <p:txBody>
+          <a:bodyPr wrap="square" lIns="0" rIns="0" tIns="0" bIns="0">
+            <a:spAutoFit/>
+          </a:bodyPr>
+          <a:lstStyle/>
+          <a:p>
+            <a:pPr algn="l"/>
+            <a:r>
+              <a:rPr sz="1100" b="0" i="0">
+                <a:solidFill>
+                  <a:srgbClr val="1A1A1A"/>
+                </a:solidFill>
+                <a:latin typeface="Calibri"/>
+              </a:rPr>
+              <a:t>~14 800 linii kodu, 130 plików</a:t>
+            </a:r>
+          </a:p>
+        </p:txBody>
+      </p:sp>
+      <p:sp>
+        <p:nvSpPr>
+          <p:cNvPr id="12" name="TextBox 11"/>
+          <p:cNvSpPr txBox="1"/>
+          <p:nvPr/>
+        </p:nvSpPr>
+        <p:spPr>
+          <a:xfrm>
+            <a:off x="540000" y="2807998"/>
+            <a:ext cx="2700000" cy="251999"/>
+          </a:xfrm>
+          <a:prstGeom prst="rect">
+            <a:avLst/>
+          </a:prstGeom>
+          <a:noFill/>
+        </p:spPr>
+        <p:txBody>
+          <a:bodyPr wrap="square" lIns="0" rIns="0" tIns="0" bIns="0">
+            <a:spAutoFit/>
+          </a:bodyPr>
+          <a:lstStyle/>
+          <a:p>
+            <a:pPr algn="l"/>
+            <a:r>
+              <a:rPr sz="1100" b="1" i="0">
+                <a:solidFill>
+                  <a:srgbClr val="1A1A1A"/>
+                </a:solidFill>
+                <a:latin typeface="Calibri"/>
+              </a:rPr>
+              <a:t>Testy</a:t>
+            </a:r>
+          </a:p>
+        </p:txBody>
+      </p:sp>
+      <p:sp>
+        <p:nvSpPr>
+          <p:cNvPr id="13" name="TextBox 12"/>
+          <p:cNvSpPr txBox="1"/>
+          <p:nvPr/>
+        </p:nvSpPr>
+        <p:spPr>
+          <a:xfrm>
+            <a:off x="3311999" y="2807998"/>
+            <a:ext cx="3168000" cy="251999"/>
+          </a:xfrm>
+          <a:prstGeom prst="rect">
+            <a:avLst/>
+          </a:prstGeom>
+          <a:noFill/>
+        </p:spPr>
+        <p:txBody>
+          <a:bodyPr wrap="square" lIns="0" rIns="0" tIns="0" bIns="0">
+            <a:spAutoFit/>
+          </a:bodyPr>
+          <a:lstStyle/>
+          <a:p>
+            <a:pPr algn="l"/>
+            <a:r>
+              <a:rPr sz="1100" b="0" i="0">
+                <a:solidFill>
+                  <a:srgbClr val="1A1A1A"/>
+                </a:solidFill>
+                <a:latin typeface="Calibri"/>
+              </a:rPr>
+              <a:t>~6 400 linii kodu</a:t>
+            </a:r>
+          </a:p>
+        </p:txBody>
+      </p:sp>
+      <p:sp>
+        <p:nvSpPr>
+          <p:cNvPr id="14" name="TextBox 13"/>
+          <p:cNvSpPr txBox="1"/>
+          <p:nvPr/>
+        </p:nvSpPr>
+        <p:spPr>
+          <a:xfrm>
+            <a:off x="540000" y="3059997"/>
+            <a:ext cx="2700000" cy="251999"/>
+          </a:xfrm>
+          <a:prstGeom prst="rect">
+            <a:avLst/>
+          </a:prstGeom>
+          <a:noFill/>
+        </p:spPr>
+        <p:txBody>
+          <a:bodyPr wrap="square" lIns="0" rIns="0" tIns="0" bIns="0">
+            <a:spAutoFit/>
+          </a:bodyPr>
+          <a:lstStyle/>
+          <a:p>
+            <a:pPr algn="l"/>
+            <a:r>
+              <a:rPr sz="1100" b="1" i="0">
+                <a:solidFill>
+                  <a:srgbClr val="1A1A1A"/>
+                </a:solidFill>
+                <a:latin typeface="Calibri"/>
+              </a:rPr>
+              <a:t>Okres realizacji</a:t>
+            </a:r>
+          </a:p>
+        </p:txBody>
+      </p:sp>
+      <p:sp>
+        <p:nvSpPr>
+          <p:cNvPr id="15" name="TextBox 14"/>
+          <p:cNvSpPr txBox="1"/>
+          <p:nvPr/>
+        </p:nvSpPr>
+        <p:spPr>
+          <a:xfrm>
+            <a:off x="3311999" y="3059997"/>
+            <a:ext cx="3168000" cy="251999"/>
+          </a:xfrm>
+          <a:prstGeom prst="rect">
+            <a:avLst/>
+          </a:prstGeom>
+          <a:noFill/>
+        </p:spPr>
+        <p:txBody>
+          <a:bodyPr wrap="square" lIns="0" rIns="0" tIns="0" bIns="0">
+            <a:spAutoFit/>
+          </a:bodyPr>
+          <a:lstStyle/>
+          <a:p>
+            <a:pPr algn="l"/>
+            <a:r>
+              <a:rPr sz="1100" b="0" i="0">
+                <a:solidFill>
+                  <a:srgbClr val="1A1A1A"/>
+                </a:solidFill>
+                <a:latin typeface="Calibri"/>
+              </a:rPr>
+              <a:t>10 marca – 15 czerwca 2026 (≈ 3 miesiące)</a:t>
+            </a:r>
+          </a:p>
+        </p:txBody>
+      </p:sp>
+      <p:sp>
+        <p:nvSpPr>
+          <p:cNvPr id="16" name="TextBox 15"/>
+          <p:cNvSpPr txBox="1"/>
+          <p:nvPr/>
+        </p:nvSpPr>
+        <p:spPr>
+          <a:xfrm>
+            <a:off x="540000" y="3311996"/>
+            <a:ext cx="2700000" cy="251999"/>
+          </a:xfrm>
+          <a:prstGeom prst="rect">
+            <a:avLst/>
+          </a:prstGeom>
+          <a:noFill/>
+        </p:spPr>
+        <p:txBody>
+          <a:bodyPr wrap="square" lIns="0" rIns="0" tIns="0" bIns="0">
+            <a:spAutoFit/>
+          </a:bodyPr>
+          <a:lstStyle/>
+          <a:p>
+            <a:pPr algn="l"/>
+            <a:r>
+              <a:rPr sz="1100" b="1" i="0">
+                <a:solidFill>
+                  <a:srgbClr val="1A1A1A"/>
+                </a:solidFill>
+                <a:latin typeface="Calibri"/>
+              </a:rPr>
+              <a:t>Zespół</a:t>
+            </a:r>
+          </a:p>
+        </p:txBody>
+      </p:sp>
+      <p:sp>
+        <p:nvSpPr>
+          <p:cNvPr id="17" name="TextBox 16"/>
+          <p:cNvSpPr txBox="1"/>
+          <p:nvPr/>
+        </p:nvSpPr>
+        <p:spPr>
+          <a:xfrm>
+            <a:off x="3311999" y="3311996"/>
+            <a:ext cx="3168000" cy="251999"/>
+          </a:xfrm>
+          <a:prstGeom prst="rect">
+            <a:avLst/>
+          </a:prstGeom>
+          <a:noFill/>
+        </p:spPr>
+        <p:txBody>
+          <a:bodyPr wrap="square" lIns="0" rIns="0" tIns="0" bIns="0">
+            <a:spAutoFit/>
+          </a:bodyPr>
+          <a:lstStyle/>
+          <a:p>
+            <a:pPr algn="l"/>
+            <a:r>
+              <a:rPr sz="1100" b="0" i="0">
+                <a:solidFill>
+                  <a:srgbClr val="1A1A1A"/>
+                </a:solidFill>
+                <a:latin typeface="Calibri"/>
+              </a:rPr>
+              <a:t>6–7 kontrybutorów, 36 PR-ów</a:t>
+            </a:r>
+          </a:p>
+        </p:txBody>
+      </p:sp>
+      <p:sp>
+        <p:nvSpPr>
+          <p:cNvPr id="18" name="TextBox 17"/>
+          <p:cNvSpPr txBox="1"/>
+          <p:nvPr/>
+        </p:nvSpPr>
+        <p:spPr>
+          <a:xfrm>
+            <a:off x="540000" y="3563995"/>
+            <a:ext cx="2700000" cy="251999"/>
+          </a:xfrm>
+          <a:prstGeom prst="rect">
+            <a:avLst/>
+          </a:prstGeom>
+          <a:noFill/>
+        </p:spPr>
+        <p:txBody>
+          <a:bodyPr wrap="square" lIns="0" rIns="0" tIns="0" bIns="0">
+            <a:spAutoFit/>
+          </a:bodyPr>
+          <a:lstStyle/>
+          <a:p>
+            <a:pPr algn="l"/>
+            <a:r>
+              <a:rPr sz="1100" b="1" i="0">
+                <a:solidFill>
+                  <a:srgbClr val="1A1A1A"/>
+                </a:solidFill>
+                <a:latin typeface="Calibri"/>
+              </a:rPr>
+              <a:t>Jakość</a:t>
+            </a:r>
+          </a:p>
+        </p:txBody>
+      </p:sp>
+      <p:sp>
+        <p:nvSpPr>
+          <p:cNvPr id="19" name="TextBox 18"/>
+          <p:cNvSpPr txBox="1"/>
+          <p:nvPr/>
+        </p:nvSpPr>
+        <p:spPr>
+          <a:xfrm>
+            <a:off x="3311999" y="3563995"/>
+            <a:ext cx="3168000" cy="251999"/>
+          </a:xfrm>
+          <a:prstGeom prst="rect">
+            <a:avLst/>
+          </a:prstGeom>
+          <a:noFill/>
+        </p:spPr>
+        <p:txBody>
+          <a:bodyPr wrap="square" lIns="0" rIns="0" tIns="0" bIns="0">
+            <a:spAutoFit/>
+          </a:bodyPr>
+          <a:lstStyle/>
+          <a:p>
+            <a:pPr algn="l"/>
+            <a:r>
+              <a:rPr sz="1100" b="0" i="0">
+                <a:solidFill>
+                  <a:srgbClr val="1A1A1A"/>
+                </a:solidFill>
+                <a:latin typeface="Calibri"/>
+              </a:rPr>
+              <a:t>CI, testy, code review, dokumentacja, solidne praktyki</a:t>
+            </a:r>
+          </a:p>
+        </p:txBody>
+      </p:sp>
+      <p:sp>
+        <p:nvSpPr>
+          <p:cNvPr id="20" name="Rounded Rectangle 19"/>
+          <p:cNvSpPr/>
+          <p:nvPr/>
+        </p:nvSpPr>
+        <p:spPr>
+          <a:xfrm>
+            <a:off x="6732000" y="1980000"/>
+            <a:ext cx="4920119" cy="4320000"/>
+          </a:xfrm>
+          <a:prstGeom prst="roundRect">
+            <a:avLst/>
+          </a:prstGeom>
+          <a:solidFill>
+            <a:srgbClr val="E8F0F9"/>
+          </a:solidFill>
+          <a:ln>
+            <a:noFill/>
+          </a:ln>
+          <a:effectLst/>
+        </p:spPr>
+        <p:style>
+          <a:lnRef idx="1">
+            <a:schemeClr val="accent1"/>
+          </a:lnRef>
+          <a:fillRef idx="3">
+            <a:schemeClr val="accent1"/>
+          </a:fillRef>
+          <a:effectRef idx="2">
+            <a:schemeClr val="accent1"/>
+          </a:effectRef>
+          <a:fontRef idx="minor">
+            <a:schemeClr val="lt1"/>
+          </a:fontRef>
+        </p:style>
+        <p:txBody>
+          <a:bodyPr rtlCol="0" anchor="ctr"/>
+          <a:lstStyle/>
+          <a:p>
+            <a:pPr algn="ctr"/>
+          </a:p>
+        </p:txBody>
+      </p:sp>
+      <p:sp>
+        <p:nvSpPr>
+          <p:cNvPr id="21" name="Rectangle 20"/>
+          <p:cNvSpPr/>
+          <p:nvPr/>
+        </p:nvSpPr>
+        <p:spPr>
+          <a:xfrm>
+            <a:off x="6732000" y="1980000"/>
+            <a:ext cx="144000" cy="4320000"/>
+          </a:xfrm>
+          <a:prstGeom prst="rect">
+            <a:avLst/>
+          </a:prstGeom>
+          <a:solidFill>
+            <a:srgbClr val="E8B44F"/>
+          </a:solidFill>
+          <a:ln>
+            <a:noFill/>
+          </a:ln>
+          <a:effectLst/>
+        </p:spPr>
+        <p:style>
+          <a:lnRef idx="1">
+            <a:schemeClr val="accent1"/>
+          </a:lnRef>
+          <a:fillRef idx="3">
+            <a:schemeClr val="accent1"/>
+          </a:fillRef>
+          <a:effectRef idx="2">
+            <a:schemeClr val="accent1"/>
+          </a:effectRef>
+          <a:fontRef idx="minor">
+            <a:schemeClr val="lt1"/>
+          </a:fontRef>
+        </p:style>
+        <p:txBody>
+          <a:bodyPr rtlCol="0" anchor="ctr"/>
+          <a:lstStyle/>
+          <a:p>
+            <a:pPr algn="ctr"/>
+          </a:p>
+        </p:txBody>
+      </p:sp>
+      <p:sp>
+        <p:nvSpPr>
+          <p:cNvPr id="22" name="TextBox 21"/>
+          <p:cNvSpPr txBox="1"/>
+          <p:nvPr/>
+        </p:nvSpPr>
+        <p:spPr>
+          <a:xfrm>
+            <a:off x="6983999" y="2160000"/>
+            <a:ext cx="4488119" cy="360000"/>
+          </a:xfrm>
+          <a:prstGeom prst="rect">
+            <a:avLst/>
+          </a:prstGeom>
+          <a:noFill/>
+        </p:spPr>
+        <p:txBody>
+          <a:bodyPr wrap="square" lIns="0" rIns="0" tIns="0" bIns="0">
+            <a:spAutoFit/>
+          </a:bodyPr>
+          <a:lstStyle/>
+          <a:p>
+            <a:pPr algn="l"/>
+            <a:r>
+              <a:rPr sz="1600" b="1" i="0">
+                <a:solidFill>
+                  <a:srgbClr val="1F4E79"/>
+                </a:solidFill>
+                <a:latin typeface="Calibri"/>
+              </a:rPr>
+              <a:t>Szacowany nakład pracy</a:t>
+            </a:r>
+          </a:p>
+        </p:txBody>
+      </p:sp>
+      <p:sp>
+        <p:nvSpPr>
+          <p:cNvPr id="23" name="TextBox 22"/>
+          <p:cNvSpPr txBox="1"/>
+          <p:nvPr/>
+        </p:nvSpPr>
+        <p:spPr>
+          <a:xfrm>
+            <a:off x="6983999" y="2592000"/>
+            <a:ext cx="4488119" cy="288000"/>
+          </a:xfrm>
+          <a:prstGeom prst="rect">
+            <a:avLst/>
+          </a:prstGeom>
+          <a:noFill/>
+        </p:spPr>
+        <p:txBody>
+          <a:bodyPr wrap="square" lIns="0" rIns="0" tIns="0" bIns="0">
+            <a:spAutoFit/>
+          </a:bodyPr>
+          <a:lstStyle/>
+          <a:p>
+            <a:pPr algn="l"/>
+            <a:r>
+              <a:rPr sz="1100" b="0" i="1">
+                <a:solidFill>
+                  <a:srgbClr val="555555"/>
+                </a:solidFill>
+                <a:latin typeface="Calibri"/>
+              </a:rPr>
+              <a:t>(blended: dev + QA + PM + design + DevOps)</a:t>
+            </a:r>
+          </a:p>
+        </p:txBody>
+      </p:sp>
+      <p:sp>
+        <p:nvSpPr>
+          <p:cNvPr id="24" name="TextBox 23"/>
+          <p:cNvSpPr txBox="1"/>
+          <p:nvPr/>
+        </p:nvSpPr>
+        <p:spPr>
+          <a:xfrm>
+            <a:off x="6983999" y="3060000"/>
+            <a:ext cx="3300119" cy="288000"/>
+          </a:xfrm>
+          <a:prstGeom prst="rect">
+            <a:avLst/>
+          </a:prstGeom>
+          <a:noFill/>
+        </p:spPr>
+        <p:txBody>
+          <a:bodyPr wrap="square" lIns="0" rIns="0" tIns="0" bIns="0">
+            <a:spAutoFit/>
+          </a:bodyPr>
+          <a:lstStyle/>
+          <a:p>
+            <a:pPr algn="l"/>
+            <a:r>
+              <a:rPr sz="1200" b="0" i="0">
+                <a:solidFill>
+                  <a:srgbClr val="1A1A1A"/>
+                </a:solidFill>
+                <a:latin typeface="Calibri"/>
+              </a:rPr>
+              <a:t>Backend</a:t>
+            </a:r>
+          </a:p>
+        </p:txBody>
+      </p:sp>
+      <p:sp>
+        <p:nvSpPr>
+          <p:cNvPr id="25" name="TextBox 24"/>
+          <p:cNvSpPr txBox="1"/>
+          <p:nvPr/>
+        </p:nvSpPr>
+        <p:spPr>
+          <a:xfrm>
+            <a:off x="10032119" y="3060000"/>
+            <a:ext cx="1368000" cy="288000"/>
+          </a:xfrm>
+          <a:prstGeom prst="rect">
+            <a:avLst/>
+          </a:prstGeom>
+          <a:noFill/>
+        </p:spPr>
+        <p:txBody>
+          <a:bodyPr wrap="square" lIns="0" rIns="0" tIns="0" bIns="0">
+            <a:spAutoFit/>
+          </a:bodyPr>
+          <a:lstStyle/>
+          <a:p>
+            <a:pPr algn="r"/>
+            <a:r>
+              <a:rPr sz="1200" b="1" i="0">
+                <a:solidFill>
+                  <a:srgbClr val="1F4E79"/>
+                </a:solidFill>
+                <a:latin typeface="Calibri"/>
+              </a:rPr>
+              <a:t>≈ 45 dni</a:t>
+            </a:r>
+          </a:p>
+        </p:txBody>
+      </p:sp>
+      <p:sp>
+        <p:nvSpPr>
+          <p:cNvPr id="26" name="TextBox 25"/>
+          <p:cNvSpPr txBox="1"/>
+          <p:nvPr/>
+        </p:nvSpPr>
+        <p:spPr>
+          <a:xfrm>
+            <a:off x="6983999" y="3420000"/>
+            <a:ext cx="3300119" cy="288000"/>
+          </a:xfrm>
+          <a:prstGeom prst="rect">
+            <a:avLst/>
+          </a:prstGeom>
+          <a:noFill/>
+        </p:spPr>
+        <p:txBody>
+          <a:bodyPr wrap="square" lIns="0" rIns="0" tIns="0" bIns="0">
+            <a:spAutoFit/>
+          </a:bodyPr>
+          <a:lstStyle/>
+          <a:p>
+            <a:pPr algn="l"/>
+            <a:r>
+              <a:rPr sz="1200" b="0" i="0">
+                <a:solidFill>
+                  <a:srgbClr val="1A1A1A"/>
+                </a:solidFill>
+                <a:latin typeface="Calibri"/>
+              </a:rPr>
+              <a:t>Frontend</a:t>
+            </a:r>
+          </a:p>
+        </p:txBody>
+      </p:sp>
+      <p:sp>
+        <p:nvSpPr>
+          <p:cNvPr id="27" name="TextBox 26"/>
+          <p:cNvSpPr txBox="1"/>
+          <p:nvPr/>
+        </p:nvSpPr>
+        <p:spPr>
+          <a:xfrm>
+            <a:off x="10032119" y="3420000"/>
+            <a:ext cx="1368000" cy="288000"/>
+          </a:xfrm>
+          <a:prstGeom prst="rect">
+            <a:avLst/>
+          </a:prstGeom>
+          <a:noFill/>
+        </p:spPr>
+        <p:txBody>
+          <a:bodyPr wrap="square" lIns="0" rIns="0" tIns="0" bIns="0">
+            <a:spAutoFit/>
+          </a:bodyPr>
+          <a:lstStyle/>
+          <a:p>
+            <a:pPr algn="r"/>
+            <a:r>
+              <a:rPr sz="1200" b="1" i="0">
+                <a:solidFill>
+                  <a:srgbClr val="1F4E79"/>
+                </a:solidFill>
+                <a:latin typeface="Calibri"/>
+              </a:rPr>
+              <a:t>≈ 55 dni</a:t>
+            </a:r>
+          </a:p>
+        </p:txBody>
+      </p:sp>
+      <p:sp>
+        <p:nvSpPr>
+          <p:cNvPr id="28" name="TextBox 27"/>
+          <p:cNvSpPr txBox="1"/>
+          <p:nvPr/>
+        </p:nvSpPr>
+        <p:spPr>
+          <a:xfrm>
+            <a:off x="6983999" y="3780000"/>
+            <a:ext cx="3300119" cy="288000"/>
+          </a:xfrm>
+          <a:prstGeom prst="rect">
+            <a:avLst/>
+          </a:prstGeom>
+          <a:noFill/>
+        </p:spPr>
+        <p:txBody>
+          <a:bodyPr wrap="square" lIns="0" rIns="0" tIns="0" bIns="0">
+            <a:spAutoFit/>
+          </a:bodyPr>
+          <a:lstStyle/>
+          <a:p>
+            <a:pPr algn="l"/>
+            <a:r>
+              <a:rPr sz="1200" b="0" i="0">
+                <a:solidFill>
+                  <a:srgbClr val="1A1A1A"/>
+                </a:solidFill>
+                <a:latin typeface="Calibri"/>
+              </a:rPr>
+              <a:t>Design, PM, QA, CI, dokumentacja</a:t>
+            </a:r>
+          </a:p>
+        </p:txBody>
+      </p:sp>
+      <p:sp>
+        <p:nvSpPr>
+          <p:cNvPr id="29" name="TextBox 28"/>
+          <p:cNvSpPr txBox="1"/>
+          <p:nvPr/>
+        </p:nvSpPr>
+        <p:spPr>
+          <a:xfrm>
+            <a:off x="10032119" y="3780000"/>
+            <a:ext cx="1368000" cy="288000"/>
+          </a:xfrm>
+          <a:prstGeom prst="rect">
+            <a:avLst/>
+          </a:prstGeom>
+          <a:noFill/>
+        </p:spPr>
+        <p:txBody>
+          <a:bodyPr wrap="square" lIns="0" rIns="0" tIns="0" bIns="0">
+            <a:spAutoFit/>
+          </a:bodyPr>
+          <a:lstStyle/>
+          <a:p>
+            <a:pPr algn="r"/>
+            <a:r>
+              <a:rPr sz="1200" b="1" i="0">
+                <a:solidFill>
+                  <a:srgbClr val="1F4E79"/>
+                </a:solidFill>
+                <a:latin typeface="Calibri"/>
+              </a:rPr>
+              <a:t>≈ 25 dni</a:t>
+            </a:r>
+          </a:p>
+        </p:txBody>
+      </p:sp>
+      <p:sp>
+        <p:nvSpPr>
+          <p:cNvPr id="30" name="Rectangle 29"/>
+          <p:cNvSpPr/>
+          <p:nvPr/>
+        </p:nvSpPr>
+        <p:spPr>
+          <a:xfrm>
+            <a:off x="6983999" y="4284000"/>
+            <a:ext cx="4416120" cy="18000"/>
+          </a:xfrm>
+          <a:prstGeom prst="rect">
+            <a:avLst/>
+          </a:prstGeom>
+          <a:solidFill>
+            <a:srgbClr val="E8B44F"/>
+          </a:solidFill>
+          <a:ln>
+            <a:noFill/>
+          </a:ln>
+          <a:effectLst/>
+        </p:spPr>
+        <p:style>
+          <a:lnRef idx="1">
+            <a:schemeClr val="accent1"/>
+          </a:lnRef>
+          <a:fillRef idx="3">
+            <a:schemeClr val="accent1"/>
+          </a:fillRef>
+          <a:effectRef idx="2">
+            <a:schemeClr val="accent1"/>
+          </a:effectRef>
+          <a:fontRef idx="minor">
+            <a:schemeClr val="lt1"/>
+          </a:fontRef>
+        </p:style>
+        <p:txBody>
+          <a:bodyPr rtlCol="0" anchor="ctr"/>
+          <a:lstStyle/>
+          <a:p>
+            <a:pPr algn="ctr"/>
+          </a:p>
+        </p:txBody>
+      </p:sp>
+      <p:sp>
+        <p:nvSpPr>
+          <p:cNvPr id="31" name="TextBox 30"/>
+          <p:cNvSpPr txBox="1"/>
+          <p:nvPr/>
+        </p:nvSpPr>
+        <p:spPr>
+          <a:xfrm>
+            <a:off x="6983999" y="4428000"/>
+            <a:ext cx="3300119" cy="288000"/>
+          </a:xfrm>
+          <a:prstGeom prst="rect">
+            <a:avLst/>
+          </a:prstGeom>
+          <a:noFill/>
+        </p:spPr>
+        <p:txBody>
+          <a:bodyPr wrap="square" lIns="0" rIns="0" tIns="0" bIns="0">
+            <a:spAutoFit/>
+          </a:bodyPr>
+          <a:lstStyle/>
+          <a:p>
+            <a:pPr algn="l"/>
+            <a:r>
+              <a:rPr sz="1400" b="1" i="0">
+                <a:solidFill>
+                  <a:srgbClr val="1A1A1A"/>
+                </a:solidFill>
+                <a:latin typeface="Calibri"/>
+              </a:rPr>
+              <a:t>Razem</a:t>
+            </a:r>
+          </a:p>
+        </p:txBody>
+      </p:sp>
+      <p:sp>
+        <p:nvSpPr>
+          <p:cNvPr id="32" name="TextBox 31"/>
+          <p:cNvSpPr txBox="1"/>
+          <p:nvPr/>
+        </p:nvSpPr>
+        <p:spPr>
+          <a:xfrm>
+            <a:off x="10032119" y="4428000"/>
+            <a:ext cx="1368000" cy="288000"/>
+          </a:xfrm>
+          <a:prstGeom prst="rect">
+            <a:avLst/>
+          </a:prstGeom>
+          <a:noFill/>
+        </p:spPr>
+        <p:txBody>
+          <a:bodyPr wrap="square" lIns="0" rIns="0" tIns="0" bIns="0">
+            <a:spAutoFit/>
+          </a:bodyPr>
+          <a:lstStyle/>
+          <a:p>
+            <a:pPr algn="r"/>
+            <a:r>
+              <a:rPr sz="1400" b="1" i="0">
+                <a:solidFill>
+                  <a:srgbClr val="2F9E44"/>
+                </a:solidFill>
+                <a:latin typeface="Calibri"/>
+              </a:rPr>
+              <a:t>≈ 120–130 osobodni</a:t>
+            </a:r>
+          </a:p>
+        </p:txBody>
+      </p:sp>
+      <p:sp>
+        <p:nvSpPr>
+          <p:cNvPr id="33" name="TextBox 32"/>
+          <p:cNvSpPr txBox="1"/>
+          <p:nvPr/>
+        </p:nvSpPr>
+        <p:spPr>
+          <a:xfrm>
+            <a:off x="6983999" y="4860000"/>
+            <a:ext cx="4416120" cy="540000"/>
+          </a:xfrm>
+          <a:prstGeom prst="rect">
+            <a:avLst/>
+          </a:prstGeom>
+          <a:noFill/>
+        </p:spPr>
+        <p:txBody>
+          <a:bodyPr wrap="square" lIns="0" rIns="0" tIns="0" bIns="0">
+            <a:spAutoFit/>
+          </a:bodyPr>
+          <a:lstStyle/>
+          <a:p>
+            <a:pPr algn="l"/>
+            <a:r>
+              <a:rPr sz="1000" b="0" i="1">
+                <a:solidFill>
+                  <a:srgbClr val="555555"/>
+                </a:solidFill>
+                <a:latin typeface="Calibri"/>
+              </a:rPr>
+              <a:t>czyli około 6 człowiekomiesięcy. Realny projekt od zera kosztuje zwykle 20–40% więcej (discovery, rework, spotkania).</a:t>
+            </a:r>
+          </a:p>
+        </p:txBody>
+      </p:sp>
+    </p:spTree>
+  </p:cSld>
+  <p:clrMapOvr>
+    <a:masterClrMapping/>
+  </p:clrMapOvr>
+</p:sld>
+</file>
+
+<file path=ppt/slides/slide21.xml><?xml version="1.0" encoding="utf-8"?>
+<p:sld xmlns:a="http://schemas.openxmlformats.org/drawingml/2006/main" xmlns:p="http://schemas.openxmlformats.org/presentationml/2006/main" xmlns:r="http://schemas.openxmlformats.org/officeDocument/2006/relationships">
+  <p:cSld>
+    <p:bg>
+      <p:bgPr>
+        <a:solidFill>
+          <a:srgbClr val="FFFFFF"/>
+        </a:solidFill>
+        <a:effectLst/>
+      </p:bgPr>
+    </p:bg>
+    <p:spTree>
+      <p:nvGrpSpPr>
+        <p:cNvPr id="1" name=""/>
+        <p:cNvGrpSpPr/>
+        <p:nvPr/>
+      </p:nvGrpSpPr>
+      <p:grpSpPr/>
+      <p:sp>
+        <p:nvSpPr>
+          <p:cNvPr id="2" name="Rectangle 1"/>
+          <p:cNvSpPr/>
+          <p:nvPr/>
+        </p:nvSpPr>
+        <p:spPr>
+          <a:xfrm>
+            <a:off x="0" y="0"/>
+            <a:ext cx="12192119" cy="720000"/>
+          </a:xfrm>
+          <a:prstGeom prst="rect">
+            <a:avLst/>
+          </a:prstGeom>
+          <a:solidFill>
+            <a:srgbClr val="1F4E79"/>
+          </a:solidFill>
+          <a:ln>
+            <a:noFill/>
+          </a:ln>
+          <a:effectLst/>
+        </p:spPr>
+        <p:style>
+          <a:lnRef idx="1">
+            <a:schemeClr val="accent1"/>
+          </a:lnRef>
+          <a:fillRef idx="3">
+            <a:schemeClr val="accent1"/>
+          </a:fillRef>
+          <a:effectRef idx="2">
+            <a:schemeClr val="accent1"/>
+          </a:effectRef>
+          <a:fontRef idx="minor">
+            <a:schemeClr val="lt1"/>
+          </a:fontRef>
+        </p:style>
+        <p:txBody>
+          <a:bodyPr rtlCol="0" anchor="ctr"/>
+          <a:lstStyle/>
+          <a:p>
+            <a:pPr algn="ctr"/>
+          </a:p>
+        </p:txBody>
+      </p:sp>
+      <p:sp>
+        <p:nvSpPr>
+          <p:cNvPr id="3" name="Rectangle 2"/>
+          <p:cNvSpPr/>
+          <p:nvPr/>
+        </p:nvSpPr>
+        <p:spPr>
+          <a:xfrm>
+            <a:off x="0" y="720000"/>
+            <a:ext cx="12192119" cy="36000"/>
+          </a:xfrm>
+          <a:prstGeom prst="rect">
+            <a:avLst/>
+          </a:prstGeom>
+          <a:solidFill>
+            <a:srgbClr val="E8B44F"/>
+          </a:solidFill>
+          <a:ln>
+            <a:noFill/>
+          </a:ln>
+          <a:effectLst/>
+        </p:spPr>
+        <p:style>
+          <a:lnRef idx="1">
+            <a:schemeClr val="accent1"/>
+          </a:lnRef>
+          <a:fillRef idx="3">
+            <a:schemeClr val="accent1"/>
+          </a:fillRef>
+          <a:effectRef idx="2">
+            <a:schemeClr val="accent1"/>
+          </a:effectRef>
+          <a:fontRef idx="minor">
+            <a:schemeClr val="lt1"/>
+          </a:fontRef>
+        </p:style>
+        <p:txBody>
+          <a:bodyPr rtlCol="0" anchor="ctr"/>
+          <a:lstStyle/>
+          <a:p>
+            <a:pPr algn="ctr"/>
+          </a:p>
+        </p:txBody>
+      </p:sp>
+      <p:sp>
+        <p:nvSpPr>
+          <p:cNvPr id="4" name="TextBox 3"/>
+          <p:cNvSpPr txBox="1"/>
+          <p:nvPr/>
+        </p:nvSpPr>
+        <p:spPr>
+          <a:xfrm>
+            <a:off x="360000" y="198000"/>
+            <a:ext cx="11472119" cy="432000"/>
+          </a:xfrm>
+          <a:prstGeom prst="rect">
+            <a:avLst/>
+          </a:prstGeom>
+          <a:noFill/>
+        </p:spPr>
+        <p:txBody>
+          <a:bodyPr wrap="square" lIns="0" rIns="0" tIns="0" bIns="0">
+            <a:spAutoFit/>
+          </a:bodyPr>
+          <a:lstStyle/>
+          <a:p>
+            <a:pPr algn="l"/>
+            <a:r>
+              <a:rPr sz="2400" b="1" i="0">
+                <a:solidFill>
+                  <a:srgbClr val="FFFFFF"/>
+                </a:solidFill>
+                <a:latin typeface="Calibri"/>
+              </a:rPr>
+              <a:t>Wycena projektu — cena dla klienta</a:t>
+            </a:r>
+          </a:p>
+        </p:txBody>
+      </p:sp>
+      <p:sp>
+        <p:nvSpPr>
+          <p:cNvPr id="5" name="TextBox 4"/>
+          <p:cNvSpPr txBox="1"/>
+          <p:nvPr/>
+        </p:nvSpPr>
+        <p:spPr>
+          <a:xfrm>
+            <a:off x="11112119" y="270000"/>
+            <a:ext cx="900000" cy="216000"/>
+          </a:xfrm>
+          <a:prstGeom prst="rect">
+            <a:avLst/>
+          </a:prstGeom>
+          <a:noFill/>
+        </p:spPr>
+        <p:txBody>
+          <a:bodyPr wrap="square" lIns="0" rIns="0" tIns="0" bIns="0">
+            <a:spAutoFit/>
+          </a:bodyPr>
+          <a:lstStyle/>
+          <a:p>
+            <a:pPr algn="r"/>
+            <a:r>
+              <a:rPr sz="1000" b="0" i="0">
+                <a:solidFill>
+                  <a:srgbClr val="E8F0F9"/>
+                </a:solidFill>
+                <a:latin typeface="Calibri"/>
+              </a:rPr>
+              <a:t>21 / 21</a:t>
+            </a:r>
+          </a:p>
+        </p:txBody>
+      </p:sp>
+      <p:sp>
+        <p:nvSpPr>
+          <p:cNvPr id="6" name="TextBox 5"/>
+          <p:cNvSpPr txBox="1"/>
+          <p:nvPr/>
+        </p:nvSpPr>
+        <p:spPr>
+          <a:xfrm>
+            <a:off x="540000" y="1007999"/>
+            <a:ext cx="11112119" cy="360000"/>
+          </a:xfrm>
+          <a:prstGeom prst="rect">
+            <a:avLst/>
+          </a:prstGeom>
+          <a:noFill/>
+        </p:spPr>
+        <p:txBody>
+          <a:bodyPr wrap="square" lIns="0" rIns="0" tIns="0" bIns="0">
+            <a:spAutoFit/>
+          </a:bodyPr>
+          <a:lstStyle/>
+          <a:p>
+            <a:pPr algn="l"/>
+            <a:r>
+              <a:rPr sz="1600" b="1" i="0">
+                <a:solidFill>
+                  <a:srgbClr val="1F4E79"/>
+                </a:solidFill>
+                <a:latin typeface="Calibri"/>
+              </a:rPr>
+              <a:t>Cena w zależności od rynku (USD)</a:t>
+            </a:r>
+          </a:p>
+        </p:txBody>
+      </p:sp>
+      <p:sp>
+        <p:nvSpPr>
+          <p:cNvPr id="7" name="Rectangle 6"/>
+          <p:cNvSpPr/>
+          <p:nvPr/>
+        </p:nvSpPr>
+        <p:spPr>
+          <a:xfrm>
+            <a:off x="540000" y="1440000"/>
+            <a:ext cx="11112119" cy="360000"/>
+          </a:xfrm>
+          <a:prstGeom prst="rect">
+            <a:avLst/>
+          </a:prstGeom>
+          <a:solidFill>
+            <a:srgbClr val="1F4E79"/>
+          </a:solidFill>
+          <a:ln>
+            <a:noFill/>
+          </a:ln>
+          <a:effectLst/>
+        </p:spPr>
+        <p:style>
+          <a:lnRef idx="1">
+            <a:schemeClr val="accent1"/>
+          </a:lnRef>
+          <a:fillRef idx="3">
+            <a:schemeClr val="accent1"/>
+          </a:fillRef>
+          <a:effectRef idx="2">
+            <a:schemeClr val="accent1"/>
+          </a:effectRef>
+          <a:fontRef idx="minor">
+            <a:schemeClr val="lt1"/>
+          </a:fontRef>
+        </p:style>
+        <p:txBody>
+          <a:bodyPr rtlCol="0" anchor="ctr"/>
+          <a:lstStyle/>
+          <a:p>
+            <a:pPr algn="ctr"/>
+          </a:p>
+        </p:txBody>
+      </p:sp>
+      <p:sp>
+        <p:nvSpPr>
+          <p:cNvPr id="8" name="TextBox 7"/>
+          <p:cNvSpPr txBox="1"/>
+          <p:nvPr/>
+        </p:nvSpPr>
+        <p:spPr>
+          <a:xfrm>
+            <a:off x="648000" y="1512000"/>
+            <a:ext cx="4464000" cy="251999"/>
+          </a:xfrm>
+          <a:prstGeom prst="rect">
+            <a:avLst/>
+          </a:prstGeom>
+          <a:noFill/>
+        </p:spPr>
+        <p:txBody>
+          <a:bodyPr wrap="square" lIns="0" rIns="0" tIns="0" bIns="0">
+            <a:spAutoFit/>
+          </a:bodyPr>
+          <a:lstStyle/>
+          <a:p>
+            <a:pPr algn="l"/>
+            <a:r>
+              <a:rPr sz="1300" b="1" i="0">
+                <a:solidFill>
+                  <a:srgbClr val="FFFFFF"/>
+                </a:solidFill>
+                <a:latin typeface="Calibri"/>
+              </a:rPr>
+              <a:t>Scenariusz</a:t>
+            </a:r>
+          </a:p>
+        </p:txBody>
+      </p:sp>
+      <p:sp>
+        <p:nvSpPr>
+          <p:cNvPr id="9" name="TextBox 8"/>
+          <p:cNvSpPr txBox="1"/>
+          <p:nvPr/>
+        </p:nvSpPr>
+        <p:spPr>
+          <a:xfrm>
+            <a:off x="5508000" y="1512000"/>
+            <a:ext cx="3204000" cy="251999"/>
+          </a:xfrm>
+          <a:prstGeom prst="rect">
+            <a:avLst/>
+          </a:prstGeom>
+          <a:noFill/>
+        </p:spPr>
+        <p:txBody>
+          <a:bodyPr wrap="square" lIns="0" rIns="0" tIns="0" bIns="0">
+            <a:spAutoFit/>
+          </a:bodyPr>
+          <a:lstStyle/>
+          <a:p>
+            <a:pPr algn="l"/>
+            <a:r>
+              <a:rPr sz="1300" b="1" i="0">
+                <a:solidFill>
+                  <a:srgbClr val="FFFFFF"/>
+                </a:solidFill>
+                <a:latin typeface="Calibri"/>
+              </a:rPr>
+              <a:t>Stawka dzienna</a:t>
+            </a:r>
+          </a:p>
+        </p:txBody>
+      </p:sp>
+      <p:sp>
+        <p:nvSpPr>
+          <p:cNvPr id="10" name="TextBox 9"/>
+          <p:cNvSpPr txBox="1"/>
+          <p:nvPr/>
+        </p:nvSpPr>
+        <p:spPr>
+          <a:xfrm>
+            <a:off x="9108000" y="1512000"/>
+            <a:ext cx="2484000" cy="251999"/>
+          </a:xfrm>
+          <a:prstGeom prst="rect">
+            <a:avLst/>
+          </a:prstGeom>
+          <a:noFill/>
+        </p:spPr>
+        <p:txBody>
+          <a:bodyPr wrap="square" lIns="0" rIns="0" tIns="0" bIns="0">
+            <a:spAutoFit/>
+          </a:bodyPr>
+          <a:lstStyle/>
+          <a:p>
+            <a:pPr algn="l"/>
+            <a:r>
+              <a:rPr sz="1300" b="1" i="0">
+                <a:solidFill>
+                  <a:srgbClr val="FFFFFF"/>
+                </a:solidFill>
+                <a:latin typeface="Calibri"/>
+              </a:rPr>
+              <a:t>Wycena projektu</a:t>
+            </a:r>
+          </a:p>
+        </p:txBody>
+      </p:sp>
+      <p:sp>
+        <p:nvSpPr>
+          <p:cNvPr id="11" name="Rectangle 10"/>
+          <p:cNvSpPr/>
+          <p:nvPr/>
+        </p:nvSpPr>
+        <p:spPr>
+          <a:xfrm>
+            <a:off x="540000" y="1800000"/>
+            <a:ext cx="11112119" cy="540000"/>
+          </a:xfrm>
+          <a:prstGeom prst="rect">
+            <a:avLst/>
+          </a:prstGeom>
+          <a:solidFill>
+            <a:srgbClr val="FFFFFF"/>
+          </a:solidFill>
+          <a:ln>
+            <a:noFill/>
+          </a:ln>
+          <a:effectLst/>
+        </p:spPr>
+        <p:style>
+          <a:lnRef idx="1">
+            <a:schemeClr val="accent1"/>
+          </a:lnRef>
+          <a:fillRef idx="3">
+            <a:schemeClr val="accent1"/>
+          </a:fillRef>
+          <a:effectRef idx="2">
+            <a:schemeClr val="accent1"/>
+          </a:effectRef>
+          <a:fontRef idx="minor">
+            <a:schemeClr val="lt1"/>
+          </a:fontRef>
+        </p:style>
+        <p:txBody>
+          <a:bodyPr rtlCol="0" anchor="ctr"/>
+          <a:lstStyle/>
+          <a:p>
+            <a:pPr algn="ctr"/>
+          </a:p>
+        </p:txBody>
+      </p:sp>
+      <p:sp>
+        <p:nvSpPr>
+          <p:cNvPr id="12" name="TextBox 11"/>
+          <p:cNvSpPr txBox="1"/>
+          <p:nvPr/>
+        </p:nvSpPr>
+        <p:spPr>
+          <a:xfrm>
+            <a:off x="648000" y="1944000"/>
+            <a:ext cx="4464000" cy="288000"/>
+          </a:xfrm>
+          <a:prstGeom prst="rect">
+            <a:avLst/>
+          </a:prstGeom>
+          <a:noFill/>
+        </p:spPr>
+        <p:txBody>
+          <a:bodyPr wrap="square" lIns="0" rIns="0" tIns="0" bIns="0">
+            <a:spAutoFit/>
+          </a:bodyPr>
+          <a:lstStyle/>
+          <a:p>
+            <a:pPr algn="l"/>
+            <a:r>
+              <a:rPr sz="1200" b="0" i="0">
+                <a:solidFill>
+                  <a:srgbClr val="1A1A1A"/>
+                </a:solidFill>
+                <a:latin typeface="Calibri"/>
+              </a:rPr>
+              <a:t>Freelancer / offshore (Azja, junior PL)</a:t>
+            </a:r>
+          </a:p>
+        </p:txBody>
+      </p:sp>
+      <p:sp>
+        <p:nvSpPr>
+          <p:cNvPr id="13" name="TextBox 12"/>
+          <p:cNvSpPr txBox="1"/>
+          <p:nvPr/>
+        </p:nvSpPr>
+        <p:spPr>
+          <a:xfrm>
+            <a:off x="5508000" y="1944000"/>
+            <a:ext cx="3204000" cy="288000"/>
+          </a:xfrm>
+          <a:prstGeom prst="rect">
+            <a:avLst/>
+          </a:prstGeom>
+          <a:noFill/>
+        </p:spPr>
+        <p:txBody>
+          <a:bodyPr wrap="square" lIns="0" rIns="0" tIns="0" bIns="0">
+            <a:spAutoFit/>
+          </a:bodyPr>
+          <a:lstStyle/>
+          <a:p>
+            <a:pPr algn="l"/>
+            <a:r>
+              <a:rPr sz="1200" b="0" i="0">
+                <a:solidFill>
+                  <a:srgbClr val="1A1A1A"/>
+                </a:solidFill>
+                <a:latin typeface="Calibri"/>
+              </a:rPr>
+              <a:t>~$250 – $350</a:t>
+            </a:r>
+          </a:p>
+        </p:txBody>
+      </p:sp>
+      <p:sp>
+        <p:nvSpPr>
+          <p:cNvPr id="14" name="TextBox 13"/>
+          <p:cNvSpPr txBox="1"/>
+          <p:nvPr/>
+        </p:nvSpPr>
+        <p:spPr>
+          <a:xfrm>
+            <a:off x="9108000" y="1944000"/>
+            <a:ext cx="2484000" cy="288000"/>
+          </a:xfrm>
+          <a:prstGeom prst="rect">
+            <a:avLst/>
+          </a:prstGeom>
+          <a:noFill/>
+        </p:spPr>
+        <p:txBody>
+          <a:bodyPr wrap="square" lIns="0" rIns="0" tIns="0" bIns="0">
+            <a:spAutoFit/>
+          </a:bodyPr>
+          <a:lstStyle/>
+          <a:p>
+            <a:pPr algn="l"/>
+            <a:r>
+              <a:rPr sz="1200" b="0" i="0">
+                <a:solidFill>
+                  <a:srgbClr val="1A1A1A"/>
+                </a:solidFill>
+                <a:latin typeface="Calibri"/>
+              </a:rPr>
+              <a:t>$30 000 – $45 000</a:t>
+            </a:r>
+          </a:p>
+        </p:txBody>
+      </p:sp>
+      <p:sp>
+        <p:nvSpPr>
+          <p:cNvPr id="15" name="Rectangle 14"/>
+          <p:cNvSpPr/>
+          <p:nvPr/>
+        </p:nvSpPr>
+        <p:spPr>
+          <a:xfrm>
+            <a:off x="540000" y="2340000"/>
+            <a:ext cx="11112119" cy="540000"/>
+          </a:xfrm>
+          <a:prstGeom prst="rect">
+            <a:avLst/>
+          </a:prstGeom>
+          <a:solidFill>
+            <a:srgbClr val="E8F0F9"/>
+          </a:solidFill>
+          <a:ln>
+            <a:noFill/>
+          </a:ln>
+          <a:effectLst/>
+        </p:spPr>
+        <p:style>
+          <a:lnRef idx="1">
+            <a:schemeClr val="accent1"/>
+          </a:lnRef>
+          <a:fillRef idx="3">
+            <a:schemeClr val="accent1"/>
+          </a:fillRef>
+          <a:effectRef idx="2">
+            <a:schemeClr val="accent1"/>
+          </a:effectRef>
+          <a:fontRef idx="minor">
+            <a:schemeClr val="lt1"/>
+          </a:fontRef>
+        </p:style>
+        <p:txBody>
+          <a:bodyPr rtlCol="0" anchor="ctr"/>
+          <a:lstStyle/>
+          <a:p>
+            <a:pPr algn="ctr"/>
+          </a:p>
+        </p:txBody>
+      </p:sp>
+      <p:sp>
+        <p:nvSpPr>
+          <p:cNvPr id="16" name="Rectangle 15"/>
+          <p:cNvSpPr/>
+          <p:nvPr/>
+        </p:nvSpPr>
+        <p:spPr>
+          <a:xfrm>
+            <a:off x="540000" y="2340000"/>
+            <a:ext cx="108000" cy="540000"/>
+          </a:xfrm>
+          <a:prstGeom prst="rect">
+            <a:avLst/>
+          </a:prstGeom>
+          <a:solidFill>
+            <a:srgbClr val="E8B44F"/>
+          </a:solidFill>
+          <a:ln>
+            <a:noFill/>
+          </a:ln>
+          <a:effectLst/>
+        </p:spPr>
+        <p:style>
+          <a:lnRef idx="1">
+            <a:schemeClr val="accent1"/>
+          </a:lnRef>
+          <a:fillRef idx="3">
+            <a:schemeClr val="accent1"/>
+          </a:fillRef>
+          <a:effectRef idx="2">
+            <a:schemeClr val="accent1"/>
+          </a:effectRef>
+          <a:fontRef idx="minor">
+            <a:schemeClr val="lt1"/>
+          </a:fontRef>
+        </p:style>
+        <p:txBody>
+          <a:bodyPr rtlCol="0" anchor="ctr"/>
+          <a:lstStyle/>
+          <a:p>
+            <a:pPr algn="ctr"/>
+          </a:p>
+        </p:txBody>
+      </p:sp>
+      <p:sp>
+        <p:nvSpPr>
+          <p:cNvPr id="17" name="TextBox 16"/>
+          <p:cNvSpPr txBox="1"/>
+          <p:nvPr/>
+        </p:nvSpPr>
+        <p:spPr>
+          <a:xfrm>
+            <a:off x="648000" y="2484000"/>
+            <a:ext cx="4464000" cy="288000"/>
+          </a:xfrm>
+          <a:prstGeom prst="rect">
+            <a:avLst/>
+          </a:prstGeom>
+          <a:noFill/>
+        </p:spPr>
+        <p:txBody>
+          <a:bodyPr wrap="square" lIns="0" rIns="0" tIns="0" bIns="0">
+            <a:spAutoFit/>
+          </a:bodyPr>
+          <a:lstStyle/>
+          <a:p>
+            <a:pPr algn="l"/>
+            <a:r>
+              <a:rPr sz="1200" b="1" i="0">
+                <a:solidFill>
+                  <a:srgbClr val="1A1A1A"/>
+                </a:solidFill>
+                <a:latin typeface="Calibri"/>
+              </a:rPr>
+              <a:t>Polski software house (typowy B2B)</a:t>
+            </a:r>
+          </a:p>
+        </p:txBody>
+      </p:sp>
+      <p:sp>
+        <p:nvSpPr>
+          <p:cNvPr id="18" name="TextBox 17"/>
+          <p:cNvSpPr txBox="1"/>
+          <p:nvPr/>
+        </p:nvSpPr>
+        <p:spPr>
+          <a:xfrm>
+            <a:off x="5508000" y="2484000"/>
+            <a:ext cx="3204000" cy="288000"/>
+          </a:xfrm>
+          <a:prstGeom prst="rect">
+            <a:avLst/>
+          </a:prstGeom>
+          <a:noFill/>
+        </p:spPr>
+        <p:txBody>
+          <a:bodyPr wrap="square" lIns="0" rIns="0" tIns="0" bIns="0">
+            <a:spAutoFit/>
+          </a:bodyPr>
+          <a:lstStyle/>
+          <a:p>
+            <a:pPr algn="l"/>
+            <a:r>
+              <a:rPr sz="1200" b="1" i="0">
+                <a:solidFill>
+                  <a:srgbClr val="1A1A1A"/>
+                </a:solidFill>
+                <a:latin typeface="Calibri"/>
+              </a:rPr>
+              <a:t>~$450 – $550</a:t>
+            </a:r>
+          </a:p>
+        </p:txBody>
+      </p:sp>
+      <p:sp>
+        <p:nvSpPr>
+          <p:cNvPr id="19" name="TextBox 18"/>
+          <p:cNvSpPr txBox="1"/>
+          <p:nvPr/>
+        </p:nvSpPr>
+        <p:spPr>
+          <a:xfrm>
+            <a:off x="9108000" y="2484000"/>
+            <a:ext cx="2484000" cy="288000"/>
+          </a:xfrm>
+          <a:prstGeom prst="rect">
+            <a:avLst/>
+          </a:prstGeom>
+          <a:noFill/>
+        </p:spPr>
+        <p:txBody>
+          <a:bodyPr wrap="square" lIns="0" rIns="0" tIns="0" bIns="0">
+            <a:spAutoFit/>
+          </a:bodyPr>
+          <a:lstStyle/>
+          <a:p>
+            <a:pPr algn="l"/>
+            <a:r>
+              <a:rPr sz="1200" b="1" i="0">
+                <a:solidFill>
+                  <a:srgbClr val="1A1A1A"/>
+                </a:solidFill>
+                <a:latin typeface="Calibri"/>
+              </a:rPr>
+              <a:t>$55 000 – $75 000</a:t>
+            </a:r>
+          </a:p>
+        </p:txBody>
+      </p:sp>
+      <p:sp>
+        <p:nvSpPr>
+          <p:cNvPr id="20" name="Rectangle 19"/>
+          <p:cNvSpPr/>
+          <p:nvPr/>
+        </p:nvSpPr>
+        <p:spPr>
+          <a:xfrm>
+            <a:off x="540000" y="2880000"/>
+            <a:ext cx="11112119" cy="540000"/>
+          </a:xfrm>
+          <a:prstGeom prst="rect">
+            <a:avLst/>
+          </a:prstGeom>
+          <a:solidFill>
+            <a:srgbClr val="FFFFFF"/>
+          </a:solidFill>
+          <a:ln>
+            <a:noFill/>
+          </a:ln>
+          <a:effectLst/>
+        </p:spPr>
+        <p:style>
+          <a:lnRef idx="1">
+            <a:schemeClr val="accent1"/>
+          </a:lnRef>
+          <a:fillRef idx="3">
+            <a:schemeClr val="accent1"/>
+          </a:fillRef>
+          <a:effectRef idx="2">
+            <a:schemeClr val="accent1"/>
+          </a:effectRef>
+          <a:fontRef idx="minor">
+            <a:schemeClr val="lt1"/>
+          </a:fontRef>
+        </p:style>
+        <p:txBody>
+          <a:bodyPr rtlCol="0" anchor="ctr"/>
+          <a:lstStyle/>
+          <a:p>
+            <a:pPr algn="ctr"/>
+          </a:p>
+        </p:txBody>
+      </p:sp>
+      <p:sp>
+        <p:nvSpPr>
+          <p:cNvPr id="21" name="TextBox 20"/>
+          <p:cNvSpPr txBox="1"/>
+          <p:nvPr/>
+        </p:nvSpPr>
+        <p:spPr>
+          <a:xfrm>
+            <a:off x="648000" y="3024000"/>
+            <a:ext cx="4464000" cy="288000"/>
+          </a:xfrm>
+          <a:prstGeom prst="rect">
+            <a:avLst/>
+          </a:prstGeom>
+          <a:noFill/>
+        </p:spPr>
+        <p:txBody>
+          <a:bodyPr wrap="square" lIns="0" rIns="0" tIns="0" bIns="0">
+            <a:spAutoFit/>
+          </a:bodyPr>
+          <a:lstStyle/>
+          <a:p>
+            <a:pPr algn="l"/>
+            <a:r>
+              <a:rPr sz="1200" b="0" i="0">
+                <a:solidFill>
+                  <a:srgbClr val="1A1A1A"/>
+                </a:solidFill>
+                <a:latin typeface="Calibri"/>
+              </a:rPr>
+              <a:t>Agencja Europa Zachodnia / US</a:t>
+            </a:r>
+          </a:p>
+        </p:txBody>
+      </p:sp>
+      <p:sp>
+        <p:nvSpPr>
+          <p:cNvPr id="22" name="TextBox 21"/>
+          <p:cNvSpPr txBox="1"/>
+          <p:nvPr/>
+        </p:nvSpPr>
+        <p:spPr>
+          <a:xfrm>
+            <a:off x="5508000" y="3024000"/>
+            <a:ext cx="3204000" cy="288000"/>
+          </a:xfrm>
+          <a:prstGeom prst="rect">
+            <a:avLst/>
+          </a:prstGeom>
+          <a:noFill/>
+        </p:spPr>
+        <p:txBody>
+          <a:bodyPr wrap="square" lIns="0" rIns="0" tIns="0" bIns="0">
+            <a:spAutoFit/>
+          </a:bodyPr>
+          <a:lstStyle/>
+          <a:p>
+            <a:pPr algn="l"/>
+            <a:r>
+              <a:rPr sz="1200" b="0" i="0">
+                <a:solidFill>
+                  <a:srgbClr val="1A1A1A"/>
+                </a:solidFill>
+                <a:latin typeface="Calibri"/>
+              </a:rPr>
+              <a:t>~$1 100 – $1 400</a:t>
+            </a:r>
+          </a:p>
+        </p:txBody>
+      </p:sp>
+      <p:sp>
+        <p:nvSpPr>
+          <p:cNvPr id="23" name="TextBox 22"/>
+          <p:cNvSpPr txBox="1"/>
+          <p:nvPr/>
+        </p:nvSpPr>
+        <p:spPr>
+          <a:xfrm>
+            <a:off x="9108000" y="3024000"/>
+            <a:ext cx="2484000" cy="288000"/>
+          </a:xfrm>
+          <a:prstGeom prst="rect">
+            <a:avLst/>
+          </a:prstGeom>
+          <a:noFill/>
+        </p:spPr>
+        <p:txBody>
+          <a:bodyPr wrap="square" lIns="0" rIns="0" tIns="0" bIns="0">
+            <a:spAutoFit/>
+          </a:bodyPr>
+          <a:lstStyle/>
+          <a:p>
+            <a:pPr algn="l"/>
+            <a:r>
+              <a:rPr sz="1200" b="0" i="0">
+                <a:solidFill>
+                  <a:srgbClr val="1A1A1A"/>
+                </a:solidFill>
+                <a:latin typeface="Calibri"/>
+              </a:rPr>
+              <a:t>$140 000 – $250 000</a:t>
+            </a:r>
+          </a:p>
+        </p:txBody>
+      </p:sp>
+      <p:sp>
+        <p:nvSpPr>
+          <p:cNvPr id="24" name="Rounded Rectangle 23"/>
+          <p:cNvSpPr/>
+          <p:nvPr/>
+        </p:nvSpPr>
+        <p:spPr>
+          <a:xfrm>
+            <a:off x="540000" y="4140000"/>
+            <a:ext cx="11112119" cy="1980000"/>
+          </a:xfrm>
+          <a:prstGeom prst="roundRect">
+            <a:avLst/>
+          </a:prstGeom>
+          <a:solidFill>
+            <a:srgbClr val="E8F0F9"/>
+          </a:solidFill>
+          <a:ln>
+            <a:noFill/>
+          </a:ln>
+          <a:effectLst/>
+        </p:spPr>
+        <p:style>
+          <a:lnRef idx="1">
+            <a:schemeClr val="accent1"/>
+          </a:lnRef>
+          <a:fillRef idx="3">
+            <a:schemeClr val="accent1"/>
+          </a:fillRef>
+          <a:effectRef idx="2">
+            <a:schemeClr val="accent1"/>
+          </a:effectRef>
+          <a:fontRef idx="minor">
+            <a:schemeClr val="lt1"/>
+          </a:fontRef>
+        </p:style>
+        <p:txBody>
+          <a:bodyPr rtlCol="0" anchor="ctr"/>
+          <a:lstStyle/>
+          <a:p>
+            <a:pPr algn="ctr"/>
+          </a:p>
+        </p:txBody>
+      </p:sp>
+      <p:sp>
+        <p:nvSpPr>
+          <p:cNvPr id="25" name="Rectangle 24"/>
+          <p:cNvSpPr/>
+          <p:nvPr/>
+        </p:nvSpPr>
+        <p:spPr>
+          <a:xfrm>
+            <a:off x="540000" y="4140000"/>
+            <a:ext cx="180000" cy="1980000"/>
+          </a:xfrm>
+          <a:prstGeom prst="rect">
+            <a:avLst/>
+          </a:prstGeom>
+          <a:solidFill>
+            <a:srgbClr val="E8B44F"/>
+          </a:solidFill>
+          <a:ln>
+            <a:noFill/>
+          </a:ln>
+          <a:effectLst/>
+        </p:spPr>
+        <p:style>
+          <a:lnRef idx="1">
+            <a:schemeClr val="accent1"/>
+          </a:lnRef>
+          <a:fillRef idx="3">
+            <a:schemeClr val="accent1"/>
+          </a:fillRef>
+          <a:effectRef idx="2">
+            <a:schemeClr val="accent1"/>
+          </a:effectRef>
+          <a:fontRef idx="minor">
+            <a:schemeClr val="lt1"/>
+          </a:fontRef>
+        </p:style>
+        <p:txBody>
+          <a:bodyPr rtlCol="0" anchor="ctr"/>
+          <a:lstStyle/>
+          <a:p>
+            <a:pPr algn="ctr"/>
+          </a:p>
+        </p:txBody>
+      </p:sp>
+      <p:sp>
+        <p:nvSpPr>
+          <p:cNvPr id="26" name="TextBox 25"/>
+          <p:cNvSpPr txBox="1"/>
+          <p:nvPr/>
+        </p:nvSpPr>
+        <p:spPr>
+          <a:xfrm>
+            <a:off x="827999" y="4356000"/>
+            <a:ext cx="10392119" cy="360000"/>
+          </a:xfrm>
+          <a:prstGeom prst="rect">
+            <a:avLst/>
+          </a:prstGeom>
+          <a:noFill/>
+        </p:spPr>
+        <p:txBody>
+          <a:bodyPr wrap="square" lIns="0" rIns="0" tIns="0" bIns="0">
+            <a:spAutoFit/>
+          </a:bodyPr>
+          <a:lstStyle/>
+          <a:p>
+            <a:pPr algn="l"/>
+            <a:r>
+              <a:rPr sz="1800" b="1" i="0">
+                <a:solidFill>
+                  <a:srgbClr val="1F4E79"/>
+                </a:solidFill>
+                <a:latin typeface="Calibri"/>
+              </a:rPr>
+              <a:t>Najbardziej prawdopodobna wycena</a:t>
+            </a:r>
+          </a:p>
+        </p:txBody>
+      </p:sp>
+      <p:sp>
+        <p:nvSpPr>
+          <p:cNvPr id="27" name="TextBox 26"/>
+          <p:cNvSpPr txBox="1"/>
+          <p:nvPr/>
+        </p:nvSpPr>
+        <p:spPr>
+          <a:xfrm>
+            <a:off x="827999" y="4788000"/>
+            <a:ext cx="10392119" cy="540000"/>
+          </a:xfrm>
+          <a:prstGeom prst="rect">
+            <a:avLst/>
+          </a:prstGeom>
+          <a:noFill/>
+        </p:spPr>
+        <p:txBody>
+          <a:bodyPr wrap="square" lIns="0" rIns="0" tIns="0" bIns="0">
+            <a:spAutoFit/>
+          </a:bodyPr>
+          <a:lstStyle/>
+          <a:p>
+            <a:pPr algn="l"/>
+            <a:r>
+              <a:rPr sz="1300" b="0" i="1">
+                <a:solidFill>
+                  <a:srgbClr val="1A1A1A"/>
+                </a:solidFill>
+                <a:latin typeface="Calibri"/>
+              </a:rPr>
+              <a:t>Polska, dojrzały produkt MVP gotowy produkcyjnie, wykonany przez polski software house:</a:t>
+            </a:r>
+          </a:p>
+        </p:txBody>
+      </p:sp>
+      <p:sp>
+        <p:nvSpPr>
+          <p:cNvPr id="28" name="TextBox 27"/>
+          <p:cNvSpPr txBox="1"/>
+          <p:nvPr/>
+        </p:nvSpPr>
+        <p:spPr>
+          <a:xfrm>
+            <a:off x="827999" y="5220000"/>
+            <a:ext cx="10392119" cy="540000"/>
+          </a:xfrm>
+          <a:prstGeom prst="rect">
+            <a:avLst/>
+          </a:prstGeom>
+          <a:noFill/>
+        </p:spPr>
+        <p:txBody>
+          <a:bodyPr wrap="square" lIns="0" rIns="0" tIns="0" bIns="0">
+            <a:spAutoFit/>
+          </a:bodyPr>
+          <a:lstStyle/>
+          <a:p>
+            <a:pPr algn="l"/>
+            <a:r>
+              <a:rPr sz="3200" b="1" i="0">
+                <a:solidFill>
+                  <a:srgbClr val="1F4E79"/>
+                </a:solidFill>
+                <a:latin typeface="Calibri"/>
+              </a:rPr>
+              <a:t>$55 000 – $75 000</a:t>
+            </a:r>
+          </a:p>
+        </p:txBody>
+      </p:sp>
+      <p:sp>
+        <p:nvSpPr>
+          <p:cNvPr id="29" name="TextBox 28"/>
+          <p:cNvSpPr txBox="1"/>
+          <p:nvPr/>
+        </p:nvSpPr>
+        <p:spPr>
+          <a:xfrm>
+            <a:off x="827999" y="5760000"/>
+            <a:ext cx="10392119" cy="288000"/>
+          </a:xfrm>
+          <a:prstGeom prst="rect">
+            <a:avLst/>
+          </a:prstGeom>
+          <a:noFill/>
+        </p:spPr>
+        <p:txBody>
+          <a:bodyPr wrap="square" lIns="0" rIns="0" tIns="0" bIns="0">
+            <a:spAutoFit/>
+          </a:bodyPr>
+          <a:lstStyle/>
+          <a:p>
+            <a:pPr algn="l"/>
+            <a:r>
+              <a:rPr sz="1300" b="0" i="1">
+                <a:solidFill>
+                  <a:srgbClr val="1A1A1A"/>
+                </a:solidFill>
+                <a:latin typeface="Calibri"/>
+              </a:rPr>
+              <a:t>Mediana wyjściowa do rozmowy z klientem: ≈ $65 000</a:t>
             </a:r>
           </a:p>
         </p:txBody>
@@ -7798,7 +10078,7 @@
                 </a:solidFill>
                 <a:latin typeface="Calibri"/>
               </a:rPr>
-              <a:t>3 / 19</a:t>
+              <a:t>3 / 21</a:t>
             </a:r>
           </a:p>
         </p:txBody>
@@ -8164,7 +10444,7 @@
                 </a:solidFill>
                 <a:latin typeface="Calibri"/>
               </a:rPr>
-              <a:t>4 / 19</a:t>
+              <a:t>4 / 21</a:t>
             </a:r>
           </a:p>
         </p:txBody>
@@ -8530,7 +10810,7 @@
                 </a:solidFill>
                 <a:latin typeface="Calibri"/>
               </a:rPr>
-              <a:t>5 / 19</a:t>
+              <a:t>5 / 21</a:t>
             </a:r>
           </a:p>
         </p:txBody>
@@ -8896,7 +11176,7 @@
                 </a:solidFill>
                 <a:latin typeface="Calibri"/>
               </a:rPr>
-              <a:t>6 / 19</a:t>
+              <a:t>6 / 21</a:t>
             </a:r>
           </a:p>
         </p:txBody>
@@ -9262,7 +11542,7 @@
                 </a:solidFill>
                 <a:latin typeface="Calibri"/>
               </a:rPr>
-              <a:t>7 / 19</a:t>
+              <a:t>7 / 21</a:t>
             </a:r>
           </a:p>
         </p:txBody>
@@ -9628,7 +11908,7 @@
                 </a:solidFill>
                 <a:latin typeface="Calibri"/>
               </a:rPr>
-              <a:t>8 / 19</a:t>
+              <a:t>8 / 21</a:t>
             </a:r>
           </a:p>
         </p:txBody>
@@ -9994,7 +12274,7 @@
                 </a:solidFill>
                 <a:latin typeface="Calibri"/>
               </a:rPr>
-              <a:t>9 / 19</a:t>
+              <a:t>9 / 21</a:t>
             </a:r>
           </a:p>
         </p:txBody>

</xml_diff>

<commit_message>
docs: rename decks (Project Presentation / Realizacja wymagań), drop estimate slides
Co-Authored-By: Claude Opus 4.8 (1M context) <noreply@anthropic.com>
</commit_message>
<xml_diff>
--- a/docs/cogniro-requirements.pptx
+++ b/docs/cogniro-requirements.pptx
@@ -24,8 +24,6 @@
     <p:sldId id="272" r:id="rId23"/>
     <p:sldId id="273" r:id="rId24"/>
     <p:sldId id="274" r:id="rId25"/>
-    <p:sldId id="275" r:id="rId26"/>
-    <p:sldId id="276" r:id="rId27"/>
   </p:sldIdLst>
   <p:sldSz cx="12192119" cy="6858000" type="screen4x3"/>
   <p:notesSz cx="6858000" cy="9144000"/>
@@ -3225,7 +3223,7 @@
                 </a:solidFill>
                 <a:latin typeface="Calibri"/>
               </a:rPr>
-              <a:t>Pokrycie wymagań funkcjonalnych — przegląd po WF01–WF21</a:t>
+              <a:t>Realizacja wymagań</a:t>
             </a:r>
           </a:p>
         </p:txBody>
@@ -3558,7 +3556,7 @@
                 </a:solidFill>
                 <a:latin typeface="Calibri"/>
               </a:rPr>
-              <a:t>10 / 21</a:t>
+              <a:t>10 / 19</a:t>
             </a:r>
           </a:p>
         </p:txBody>
@@ -3924,7 +3922,7 @@
                 </a:solidFill>
                 <a:latin typeface="Calibri"/>
               </a:rPr>
-              <a:t>11 / 21</a:t>
+              <a:t>11 / 19</a:t>
             </a:r>
           </a:p>
         </p:txBody>
@@ -4290,7 +4288,7 @@
                 </a:solidFill>
                 <a:latin typeface="Calibri"/>
               </a:rPr>
-              <a:t>12 / 21</a:t>
+              <a:t>12 / 19</a:t>
             </a:r>
           </a:p>
         </p:txBody>
@@ -4656,7 +4654,7 @@
                 </a:solidFill>
                 <a:latin typeface="Calibri"/>
               </a:rPr>
-              <a:t>13 / 21</a:t>
+              <a:t>13 / 19</a:t>
             </a:r>
           </a:p>
         </p:txBody>
@@ -5022,7 +5020,7 @@
                 </a:solidFill>
                 <a:latin typeface="Calibri"/>
               </a:rPr>
-              <a:t>14 / 21</a:t>
+              <a:t>14 / 19</a:t>
             </a:r>
           </a:p>
         </p:txBody>
@@ -5388,7 +5386,7 @@
                 </a:solidFill>
                 <a:latin typeface="Calibri"/>
               </a:rPr>
-              <a:t>15 / 21</a:t>
+              <a:t>15 / 19</a:t>
             </a:r>
           </a:p>
         </p:txBody>
@@ -5754,7 +5752,7 @@
                 </a:solidFill>
                 <a:latin typeface="Calibri"/>
               </a:rPr>
-              <a:t>16 / 21</a:t>
+              <a:t>16 / 19</a:t>
             </a:r>
           </a:p>
         </p:txBody>
@@ -6120,7 +6118,7 @@
                 </a:solidFill>
                 <a:latin typeface="Calibri"/>
               </a:rPr>
-              <a:t>17 / 21</a:t>
+              <a:t>17 / 19</a:t>
             </a:r>
           </a:p>
         </p:txBody>
@@ -6486,7 +6484,7 @@
                 </a:solidFill>
                 <a:latin typeface="Calibri"/>
               </a:rPr>
-              <a:t>18 / 21</a:t>
+              <a:t>18 / 19</a:t>
             </a:r>
           </a:p>
         </p:txBody>
@@ -6773,7 +6771,7 @@
                 </a:solidFill>
                 <a:latin typeface="Calibri"/>
               </a:rPr>
-              <a:t>19 / 21</a:t>
+              <a:t>19 / 19</a:t>
             </a:r>
           </a:p>
         </p:txBody>
@@ -7434,7 +7432,7 @@
                 </a:solidFill>
                 <a:latin typeface="Calibri"/>
               </a:rPr>
-              <a:t>2 / 21</a:t>
+              <a:t>2 / 19</a:t>
             </a:r>
           </a:p>
         </p:txBody>
@@ -7538,2284 +7536,6 @@
                 <a:latin typeface="Calibri"/>
               </a:rPr>
               <a:t>W edytorze administrator wpisuje treść pytania, dodaje listę odpowiedzi i zaznacza tę poprawną (radio button po lewej każdej opcji).</a:t>
-            </a:r>
-          </a:p>
-        </p:txBody>
-      </p:sp>
-    </p:spTree>
-  </p:cSld>
-  <p:clrMapOvr>
-    <a:masterClrMapping/>
-  </p:clrMapOvr>
-</p:sld>
-</file>
-
-<file path=ppt/slides/slide20.xml><?xml version="1.0" encoding="utf-8"?>
-<p:sld xmlns:a="http://schemas.openxmlformats.org/drawingml/2006/main" xmlns:p="http://schemas.openxmlformats.org/presentationml/2006/main" xmlns:r="http://schemas.openxmlformats.org/officeDocument/2006/relationships">
-  <p:cSld>
-    <p:bg>
-      <p:bgPr>
-        <a:solidFill>
-          <a:srgbClr val="FFFFFF"/>
-        </a:solidFill>
-        <a:effectLst/>
-      </p:bgPr>
-    </p:bg>
-    <p:spTree>
-      <p:nvGrpSpPr>
-        <p:cNvPr id="1" name=""/>
-        <p:cNvGrpSpPr/>
-        <p:nvPr/>
-      </p:nvGrpSpPr>
-      <p:grpSpPr/>
-      <p:sp>
-        <p:nvSpPr>
-          <p:cNvPr id="2" name="Rectangle 1"/>
-          <p:cNvSpPr/>
-          <p:nvPr/>
-        </p:nvSpPr>
-        <p:spPr>
-          <a:xfrm>
-            <a:off x="0" y="0"/>
-            <a:ext cx="12192119" cy="720000"/>
-          </a:xfrm>
-          <a:prstGeom prst="rect">
-            <a:avLst/>
-          </a:prstGeom>
-          <a:solidFill>
-            <a:srgbClr val="1F4E79"/>
-          </a:solidFill>
-          <a:ln>
-            <a:noFill/>
-          </a:ln>
-          <a:effectLst/>
-        </p:spPr>
-        <p:style>
-          <a:lnRef idx="1">
-            <a:schemeClr val="accent1"/>
-          </a:lnRef>
-          <a:fillRef idx="3">
-            <a:schemeClr val="accent1"/>
-          </a:fillRef>
-          <a:effectRef idx="2">
-            <a:schemeClr val="accent1"/>
-          </a:effectRef>
-          <a:fontRef idx="minor">
-            <a:schemeClr val="lt1"/>
-          </a:fontRef>
-        </p:style>
-        <p:txBody>
-          <a:bodyPr rtlCol="0" anchor="ctr"/>
-          <a:lstStyle/>
-          <a:p>
-            <a:pPr algn="ctr"/>
-          </a:p>
-        </p:txBody>
-      </p:sp>
-      <p:sp>
-        <p:nvSpPr>
-          <p:cNvPr id="3" name="Rectangle 2"/>
-          <p:cNvSpPr/>
-          <p:nvPr/>
-        </p:nvSpPr>
-        <p:spPr>
-          <a:xfrm>
-            <a:off x="0" y="720000"/>
-            <a:ext cx="12192119" cy="36000"/>
-          </a:xfrm>
-          <a:prstGeom prst="rect">
-            <a:avLst/>
-          </a:prstGeom>
-          <a:solidFill>
-            <a:srgbClr val="E8B44F"/>
-          </a:solidFill>
-          <a:ln>
-            <a:noFill/>
-          </a:ln>
-          <a:effectLst/>
-        </p:spPr>
-        <p:style>
-          <a:lnRef idx="1">
-            <a:schemeClr val="accent1"/>
-          </a:lnRef>
-          <a:fillRef idx="3">
-            <a:schemeClr val="accent1"/>
-          </a:fillRef>
-          <a:effectRef idx="2">
-            <a:schemeClr val="accent1"/>
-          </a:effectRef>
-          <a:fontRef idx="minor">
-            <a:schemeClr val="lt1"/>
-          </a:fontRef>
-        </p:style>
-        <p:txBody>
-          <a:bodyPr rtlCol="0" anchor="ctr"/>
-          <a:lstStyle/>
-          <a:p>
-            <a:pPr algn="ctr"/>
-          </a:p>
-        </p:txBody>
-      </p:sp>
-      <p:sp>
-        <p:nvSpPr>
-          <p:cNvPr id="4" name="TextBox 3"/>
-          <p:cNvSpPr txBox="1"/>
-          <p:nvPr/>
-        </p:nvSpPr>
-        <p:spPr>
-          <a:xfrm>
-            <a:off x="360000" y="198000"/>
-            <a:ext cx="11472119" cy="432000"/>
-          </a:xfrm>
-          <a:prstGeom prst="rect">
-            <a:avLst/>
-          </a:prstGeom>
-          <a:noFill/>
-        </p:spPr>
-        <p:txBody>
-          <a:bodyPr wrap="square" lIns="0" rIns="0" tIns="0" bIns="0">
-            <a:spAutoFit/>
-          </a:bodyPr>
-          <a:lstStyle/>
-          <a:p>
-            <a:pPr algn="l"/>
-            <a:r>
-              <a:rPr sz="2400" b="1" i="0">
-                <a:solidFill>
-                  <a:srgbClr val="FFFFFF"/>
-                </a:solidFill>
-                <a:latin typeface="Calibri"/>
-              </a:rPr>
-              <a:t>Wycena projektu — zakres i nakład pracy</a:t>
-            </a:r>
-          </a:p>
-        </p:txBody>
-      </p:sp>
-      <p:sp>
-        <p:nvSpPr>
-          <p:cNvPr id="5" name="TextBox 4"/>
-          <p:cNvSpPr txBox="1"/>
-          <p:nvPr/>
-        </p:nvSpPr>
-        <p:spPr>
-          <a:xfrm>
-            <a:off x="11112119" y="270000"/>
-            <a:ext cx="900000" cy="216000"/>
-          </a:xfrm>
-          <a:prstGeom prst="rect">
-            <a:avLst/>
-          </a:prstGeom>
-          <a:noFill/>
-        </p:spPr>
-        <p:txBody>
-          <a:bodyPr wrap="square" lIns="0" rIns="0" tIns="0" bIns="0">
-            <a:spAutoFit/>
-          </a:bodyPr>
-          <a:lstStyle/>
-          <a:p>
-            <a:pPr algn="r"/>
-            <a:r>
-              <a:rPr sz="1000" b="0" i="0">
-                <a:solidFill>
-                  <a:srgbClr val="E8F0F9"/>
-                </a:solidFill>
-                <a:latin typeface="Calibri"/>
-              </a:rPr>
-              <a:t>20 / 21</a:t>
-            </a:r>
-          </a:p>
-        </p:txBody>
-      </p:sp>
-      <p:sp>
-        <p:nvSpPr>
-          <p:cNvPr id="6" name="TextBox 5"/>
-          <p:cNvSpPr txBox="1"/>
-          <p:nvPr/>
-        </p:nvSpPr>
-        <p:spPr>
-          <a:xfrm>
-            <a:off x="540000" y="1007999"/>
-            <a:ext cx="11112119" cy="720000"/>
-          </a:xfrm>
-          <a:prstGeom prst="rect">
-            <a:avLst/>
-          </a:prstGeom>
-          <a:noFill/>
-        </p:spPr>
-        <p:txBody>
-          <a:bodyPr wrap="square" lIns="0" rIns="0" tIns="0" bIns="0">
-            <a:spAutoFit/>
-          </a:bodyPr>
-          <a:lstStyle/>
-          <a:p>
-            <a:pPr algn="l"/>
-            <a:r>
-              <a:rPr sz="1300" b="0" i="1">
-                <a:solidFill>
-                  <a:srgbClr val="1A1A1A"/>
-                </a:solidFill>
-                <a:latin typeface="Calibri"/>
-              </a:rPr>
-              <a:t>Wycena oparta na faktycznym, zinwentaryzowanym zakresie repozytorium. Platforma do quizów na żywo z panelem administratora, edytorem quizów, trybem prezentera, sesjami na PIN, leaderboardem na żywo, archiwum wyników oraz importem i eksportem.</a:t>
-            </a:r>
-          </a:p>
-        </p:txBody>
-      </p:sp>
-      <p:sp>
-        <p:nvSpPr>
-          <p:cNvPr id="7" name="TextBox 6"/>
-          <p:cNvSpPr txBox="1"/>
-          <p:nvPr/>
-        </p:nvSpPr>
-        <p:spPr>
-          <a:xfrm>
-            <a:off x="540000" y="1980000"/>
-            <a:ext cx="5400000" cy="288000"/>
-          </a:xfrm>
-          <a:prstGeom prst="rect">
-            <a:avLst/>
-          </a:prstGeom>
-          <a:noFill/>
-        </p:spPr>
-        <p:txBody>
-          <a:bodyPr wrap="square" lIns="0" rIns="0" tIns="0" bIns="0">
-            <a:spAutoFit/>
-          </a:bodyPr>
-          <a:lstStyle/>
-          <a:p>
-            <a:pPr algn="l"/>
-            <a:r>
-              <a:rPr sz="1500" b="1" i="0">
-                <a:solidFill>
-                  <a:srgbClr val="1F4E79"/>
-                </a:solidFill>
-                <a:latin typeface="Calibri"/>
-              </a:rPr>
-              <a:t>Zmierzony rozmiar</a:t>
-            </a:r>
-          </a:p>
-        </p:txBody>
-      </p:sp>
-      <p:sp>
-        <p:nvSpPr>
-          <p:cNvPr id="8" name="TextBox 7"/>
-          <p:cNvSpPr txBox="1"/>
-          <p:nvPr/>
-        </p:nvSpPr>
-        <p:spPr>
-          <a:xfrm>
-            <a:off x="540000" y="2304000"/>
-            <a:ext cx="2700000" cy="251999"/>
-          </a:xfrm>
-          <a:prstGeom prst="rect">
-            <a:avLst/>
-          </a:prstGeom>
-          <a:noFill/>
-        </p:spPr>
-        <p:txBody>
-          <a:bodyPr wrap="square" lIns="0" rIns="0" tIns="0" bIns="0">
-            <a:spAutoFit/>
-          </a:bodyPr>
-          <a:lstStyle/>
-          <a:p>
-            <a:pPr algn="l"/>
-            <a:r>
-              <a:rPr sz="1100" b="1" i="0">
-                <a:solidFill>
-                  <a:srgbClr val="1A1A1A"/>
-                </a:solidFill>
-                <a:latin typeface="Calibri"/>
-              </a:rPr>
-              <a:t>Backend (FastAPI, Python)</a:t>
-            </a:r>
-          </a:p>
-        </p:txBody>
-      </p:sp>
-      <p:sp>
-        <p:nvSpPr>
-          <p:cNvPr id="9" name="TextBox 8"/>
-          <p:cNvSpPr txBox="1"/>
-          <p:nvPr/>
-        </p:nvSpPr>
-        <p:spPr>
-          <a:xfrm>
-            <a:off x="3311999" y="2304000"/>
-            <a:ext cx="3168000" cy="251999"/>
-          </a:xfrm>
-          <a:prstGeom prst="rect">
-            <a:avLst/>
-          </a:prstGeom>
-          <a:noFill/>
-        </p:spPr>
-        <p:txBody>
-          <a:bodyPr wrap="square" lIns="0" rIns="0" tIns="0" bIns="0">
-            <a:spAutoFit/>
-          </a:bodyPr>
-          <a:lstStyle/>
-          <a:p>
-            <a:pPr algn="l"/>
-            <a:r>
-              <a:rPr sz="1100" b="0" i="0">
-                <a:solidFill>
-                  <a:srgbClr val="1A1A1A"/>
-                </a:solidFill>
-                <a:latin typeface="Calibri"/>
-              </a:rPr>
-              <a:t>~9 300 linii kodu, 60 plików</a:t>
-            </a:r>
-          </a:p>
-        </p:txBody>
-      </p:sp>
-      <p:sp>
-        <p:nvSpPr>
-          <p:cNvPr id="10" name="TextBox 9"/>
-          <p:cNvSpPr txBox="1"/>
-          <p:nvPr/>
-        </p:nvSpPr>
-        <p:spPr>
-          <a:xfrm>
-            <a:off x="540000" y="2555999"/>
-            <a:ext cx="2700000" cy="251999"/>
-          </a:xfrm>
-          <a:prstGeom prst="rect">
-            <a:avLst/>
-          </a:prstGeom>
-          <a:noFill/>
-        </p:spPr>
-        <p:txBody>
-          <a:bodyPr wrap="square" lIns="0" rIns="0" tIns="0" bIns="0">
-            <a:spAutoFit/>
-          </a:bodyPr>
-          <a:lstStyle/>
-          <a:p>
-            <a:pPr algn="l"/>
-            <a:r>
-              <a:rPr sz="1100" b="1" i="0">
-                <a:solidFill>
-                  <a:srgbClr val="1A1A1A"/>
-                </a:solidFill>
-                <a:latin typeface="Calibri"/>
-              </a:rPr>
-              <a:t>Frontend (Next.js)</a:t>
-            </a:r>
-          </a:p>
-        </p:txBody>
-      </p:sp>
-      <p:sp>
-        <p:nvSpPr>
-          <p:cNvPr id="11" name="TextBox 10"/>
-          <p:cNvSpPr txBox="1"/>
-          <p:nvPr/>
-        </p:nvSpPr>
-        <p:spPr>
-          <a:xfrm>
-            <a:off x="3311999" y="2555999"/>
-            <a:ext cx="3168000" cy="251999"/>
-          </a:xfrm>
-          <a:prstGeom prst="rect">
-            <a:avLst/>
-          </a:prstGeom>
-          <a:noFill/>
-        </p:spPr>
-        <p:txBody>
-          <a:bodyPr wrap="square" lIns="0" rIns="0" tIns="0" bIns="0">
-            <a:spAutoFit/>
-          </a:bodyPr>
-          <a:lstStyle/>
-          <a:p>
-            <a:pPr algn="l"/>
-            <a:r>
-              <a:rPr sz="1100" b="0" i="0">
-                <a:solidFill>
-                  <a:srgbClr val="1A1A1A"/>
-                </a:solidFill>
-                <a:latin typeface="Calibri"/>
-              </a:rPr>
-              <a:t>~14 800 linii kodu, 130 plików</a:t>
-            </a:r>
-          </a:p>
-        </p:txBody>
-      </p:sp>
-      <p:sp>
-        <p:nvSpPr>
-          <p:cNvPr id="12" name="TextBox 11"/>
-          <p:cNvSpPr txBox="1"/>
-          <p:nvPr/>
-        </p:nvSpPr>
-        <p:spPr>
-          <a:xfrm>
-            <a:off x="540000" y="2807998"/>
-            <a:ext cx="2700000" cy="251999"/>
-          </a:xfrm>
-          <a:prstGeom prst="rect">
-            <a:avLst/>
-          </a:prstGeom>
-          <a:noFill/>
-        </p:spPr>
-        <p:txBody>
-          <a:bodyPr wrap="square" lIns="0" rIns="0" tIns="0" bIns="0">
-            <a:spAutoFit/>
-          </a:bodyPr>
-          <a:lstStyle/>
-          <a:p>
-            <a:pPr algn="l"/>
-            <a:r>
-              <a:rPr sz="1100" b="1" i="0">
-                <a:solidFill>
-                  <a:srgbClr val="1A1A1A"/>
-                </a:solidFill>
-                <a:latin typeface="Calibri"/>
-              </a:rPr>
-              <a:t>Testy</a:t>
-            </a:r>
-          </a:p>
-        </p:txBody>
-      </p:sp>
-      <p:sp>
-        <p:nvSpPr>
-          <p:cNvPr id="13" name="TextBox 12"/>
-          <p:cNvSpPr txBox="1"/>
-          <p:nvPr/>
-        </p:nvSpPr>
-        <p:spPr>
-          <a:xfrm>
-            <a:off x="3311999" y="2807998"/>
-            <a:ext cx="3168000" cy="251999"/>
-          </a:xfrm>
-          <a:prstGeom prst="rect">
-            <a:avLst/>
-          </a:prstGeom>
-          <a:noFill/>
-        </p:spPr>
-        <p:txBody>
-          <a:bodyPr wrap="square" lIns="0" rIns="0" tIns="0" bIns="0">
-            <a:spAutoFit/>
-          </a:bodyPr>
-          <a:lstStyle/>
-          <a:p>
-            <a:pPr algn="l"/>
-            <a:r>
-              <a:rPr sz="1100" b="0" i="0">
-                <a:solidFill>
-                  <a:srgbClr val="1A1A1A"/>
-                </a:solidFill>
-                <a:latin typeface="Calibri"/>
-              </a:rPr>
-              <a:t>~6 400 linii kodu</a:t>
-            </a:r>
-          </a:p>
-        </p:txBody>
-      </p:sp>
-      <p:sp>
-        <p:nvSpPr>
-          <p:cNvPr id="14" name="TextBox 13"/>
-          <p:cNvSpPr txBox="1"/>
-          <p:nvPr/>
-        </p:nvSpPr>
-        <p:spPr>
-          <a:xfrm>
-            <a:off x="540000" y="3059997"/>
-            <a:ext cx="2700000" cy="251999"/>
-          </a:xfrm>
-          <a:prstGeom prst="rect">
-            <a:avLst/>
-          </a:prstGeom>
-          <a:noFill/>
-        </p:spPr>
-        <p:txBody>
-          <a:bodyPr wrap="square" lIns="0" rIns="0" tIns="0" bIns="0">
-            <a:spAutoFit/>
-          </a:bodyPr>
-          <a:lstStyle/>
-          <a:p>
-            <a:pPr algn="l"/>
-            <a:r>
-              <a:rPr sz="1100" b="1" i="0">
-                <a:solidFill>
-                  <a:srgbClr val="1A1A1A"/>
-                </a:solidFill>
-                <a:latin typeface="Calibri"/>
-              </a:rPr>
-              <a:t>Okres realizacji</a:t>
-            </a:r>
-          </a:p>
-        </p:txBody>
-      </p:sp>
-      <p:sp>
-        <p:nvSpPr>
-          <p:cNvPr id="15" name="TextBox 14"/>
-          <p:cNvSpPr txBox="1"/>
-          <p:nvPr/>
-        </p:nvSpPr>
-        <p:spPr>
-          <a:xfrm>
-            <a:off x="3311999" y="3059997"/>
-            <a:ext cx="3168000" cy="251999"/>
-          </a:xfrm>
-          <a:prstGeom prst="rect">
-            <a:avLst/>
-          </a:prstGeom>
-          <a:noFill/>
-        </p:spPr>
-        <p:txBody>
-          <a:bodyPr wrap="square" lIns="0" rIns="0" tIns="0" bIns="0">
-            <a:spAutoFit/>
-          </a:bodyPr>
-          <a:lstStyle/>
-          <a:p>
-            <a:pPr algn="l"/>
-            <a:r>
-              <a:rPr sz="1100" b="0" i="0">
-                <a:solidFill>
-                  <a:srgbClr val="1A1A1A"/>
-                </a:solidFill>
-                <a:latin typeface="Calibri"/>
-              </a:rPr>
-              <a:t>10 marca – 15 czerwca 2026 (≈ 3 miesiące)</a:t>
-            </a:r>
-          </a:p>
-        </p:txBody>
-      </p:sp>
-      <p:sp>
-        <p:nvSpPr>
-          <p:cNvPr id="16" name="TextBox 15"/>
-          <p:cNvSpPr txBox="1"/>
-          <p:nvPr/>
-        </p:nvSpPr>
-        <p:spPr>
-          <a:xfrm>
-            <a:off x="540000" y="3311996"/>
-            <a:ext cx="2700000" cy="251999"/>
-          </a:xfrm>
-          <a:prstGeom prst="rect">
-            <a:avLst/>
-          </a:prstGeom>
-          <a:noFill/>
-        </p:spPr>
-        <p:txBody>
-          <a:bodyPr wrap="square" lIns="0" rIns="0" tIns="0" bIns="0">
-            <a:spAutoFit/>
-          </a:bodyPr>
-          <a:lstStyle/>
-          <a:p>
-            <a:pPr algn="l"/>
-            <a:r>
-              <a:rPr sz="1100" b="1" i="0">
-                <a:solidFill>
-                  <a:srgbClr val="1A1A1A"/>
-                </a:solidFill>
-                <a:latin typeface="Calibri"/>
-              </a:rPr>
-              <a:t>Zespół</a:t>
-            </a:r>
-          </a:p>
-        </p:txBody>
-      </p:sp>
-      <p:sp>
-        <p:nvSpPr>
-          <p:cNvPr id="17" name="TextBox 16"/>
-          <p:cNvSpPr txBox="1"/>
-          <p:nvPr/>
-        </p:nvSpPr>
-        <p:spPr>
-          <a:xfrm>
-            <a:off x="3311999" y="3311996"/>
-            <a:ext cx="3168000" cy="251999"/>
-          </a:xfrm>
-          <a:prstGeom prst="rect">
-            <a:avLst/>
-          </a:prstGeom>
-          <a:noFill/>
-        </p:spPr>
-        <p:txBody>
-          <a:bodyPr wrap="square" lIns="0" rIns="0" tIns="0" bIns="0">
-            <a:spAutoFit/>
-          </a:bodyPr>
-          <a:lstStyle/>
-          <a:p>
-            <a:pPr algn="l"/>
-            <a:r>
-              <a:rPr sz="1100" b="0" i="0">
-                <a:solidFill>
-                  <a:srgbClr val="1A1A1A"/>
-                </a:solidFill>
-                <a:latin typeface="Calibri"/>
-              </a:rPr>
-              <a:t>6–7 kontrybutorów, 36 PR-ów</a:t>
-            </a:r>
-          </a:p>
-        </p:txBody>
-      </p:sp>
-      <p:sp>
-        <p:nvSpPr>
-          <p:cNvPr id="18" name="TextBox 17"/>
-          <p:cNvSpPr txBox="1"/>
-          <p:nvPr/>
-        </p:nvSpPr>
-        <p:spPr>
-          <a:xfrm>
-            <a:off x="540000" y="3563995"/>
-            <a:ext cx="2700000" cy="251999"/>
-          </a:xfrm>
-          <a:prstGeom prst="rect">
-            <a:avLst/>
-          </a:prstGeom>
-          <a:noFill/>
-        </p:spPr>
-        <p:txBody>
-          <a:bodyPr wrap="square" lIns="0" rIns="0" tIns="0" bIns="0">
-            <a:spAutoFit/>
-          </a:bodyPr>
-          <a:lstStyle/>
-          <a:p>
-            <a:pPr algn="l"/>
-            <a:r>
-              <a:rPr sz="1100" b="1" i="0">
-                <a:solidFill>
-                  <a:srgbClr val="1A1A1A"/>
-                </a:solidFill>
-                <a:latin typeface="Calibri"/>
-              </a:rPr>
-              <a:t>Jakość</a:t>
-            </a:r>
-          </a:p>
-        </p:txBody>
-      </p:sp>
-      <p:sp>
-        <p:nvSpPr>
-          <p:cNvPr id="19" name="TextBox 18"/>
-          <p:cNvSpPr txBox="1"/>
-          <p:nvPr/>
-        </p:nvSpPr>
-        <p:spPr>
-          <a:xfrm>
-            <a:off x="3311999" y="3563995"/>
-            <a:ext cx="3168000" cy="251999"/>
-          </a:xfrm>
-          <a:prstGeom prst="rect">
-            <a:avLst/>
-          </a:prstGeom>
-          <a:noFill/>
-        </p:spPr>
-        <p:txBody>
-          <a:bodyPr wrap="square" lIns="0" rIns="0" tIns="0" bIns="0">
-            <a:spAutoFit/>
-          </a:bodyPr>
-          <a:lstStyle/>
-          <a:p>
-            <a:pPr algn="l"/>
-            <a:r>
-              <a:rPr sz="1100" b="0" i="0">
-                <a:solidFill>
-                  <a:srgbClr val="1A1A1A"/>
-                </a:solidFill>
-                <a:latin typeface="Calibri"/>
-              </a:rPr>
-              <a:t>CI, testy, code review, dokumentacja, solidne praktyki</a:t>
-            </a:r>
-          </a:p>
-        </p:txBody>
-      </p:sp>
-      <p:sp>
-        <p:nvSpPr>
-          <p:cNvPr id="20" name="Rounded Rectangle 19"/>
-          <p:cNvSpPr/>
-          <p:nvPr/>
-        </p:nvSpPr>
-        <p:spPr>
-          <a:xfrm>
-            <a:off x="6732000" y="1980000"/>
-            <a:ext cx="4920119" cy="4320000"/>
-          </a:xfrm>
-          <a:prstGeom prst="roundRect">
-            <a:avLst/>
-          </a:prstGeom>
-          <a:solidFill>
-            <a:srgbClr val="E8F0F9"/>
-          </a:solidFill>
-          <a:ln>
-            <a:noFill/>
-          </a:ln>
-          <a:effectLst/>
-        </p:spPr>
-        <p:style>
-          <a:lnRef idx="1">
-            <a:schemeClr val="accent1"/>
-          </a:lnRef>
-          <a:fillRef idx="3">
-            <a:schemeClr val="accent1"/>
-          </a:fillRef>
-          <a:effectRef idx="2">
-            <a:schemeClr val="accent1"/>
-          </a:effectRef>
-          <a:fontRef idx="minor">
-            <a:schemeClr val="lt1"/>
-          </a:fontRef>
-        </p:style>
-        <p:txBody>
-          <a:bodyPr rtlCol="0" anchor="ctr"/>
-          <a:lstStyle/>
-          <a:p>
-            <a:pPr algn="ctr"/>
-          </a:p>
-        </p:txBody>
-      </p:sp>
-      <p:sp>
-        <p:nvSpPr>
-          <p:cNvPr id="21" name="Rectangle 20"/>
-          <p:cNvSpPr/>
-          <p:nvPr/>
-        </p:nvSpPr>
-        <p:spPr>
-          <a:xfrm>
-            <a:off x="6732000" y="1980000"/>
-            <a:ext cx="144000" cy="4320000"/>
-          </a:xfrm>
-          <a:prstGeom prst="rect">
-            <a:avLst/>
-          </a:prstGeom>
-          <a:solidFill>
-            <a:srgbClr val="E8B44F"/>
-          </a:solidFill>
-          <a:ln>
-            <a:noFill/>
-          </a:ln>
-          <a:effectLst/>
-        </p:spPr>
-        <p:style>
-          <a:lnRef idx="1">
-            <a:schemeClr val="accent1"/>
-          </a:lnRef>
-          <a:fillRef idx="3">
-            <a:schemeClr val="accent1"/>
-          </a:fillRef>
-          <a:effectRef idx="2">
-            <a:schemeClr val="accent1"/>
-          </a:effectRef>
-          <a:fontRef idx="minor">
-            <a:schemeClr val="lt1"/>
-          </a:fontRef>
-        </p:style>
-        <p:txBody>
-          <a:bodyPr rtlCol="0" anchor="ctr"/>
-          <a:lstStyle/>
-          <a:p>
-            <a:pPr algn="ctr"/>
-          </a:p>
-        </p:txBody>
-      </p:sp>
-      <p:sp>
-        <p:nvSpPr>
-          <p:cNvPr id="22" name="TextBox 21"/>
-          <p:cNvSpPr txBox="1"/>
-          <p:nvPr/>
-        </p:nvSpPr>
-        <p:spPr>
-          <a:xfrm>
-            <a:off x="6983999" y="2160000"/>
-            <a:ext cx="4488119" cy="360000"/>
-          </a:xfrm>
-          <a:prstGeom prst="rect">
-            <a:avLst/>
-          </a:prstGeom>
-          <a:noFill/>
-        </p:spPr>
-        <p:txBody>
-          <a:bodyPr wrap="square" lIns="0" rIns="0" tIns="0" bIns="0">
-            <a:spAutoFit/>
-          </a:bodyPr>
-          <a:lstStyle/>
-          <a:p>
-            <a:pPr algn="l"/>
-            <a:r>
-              <a:rPr sz="1600" b="1" i="0">
-                <a:solidFill>
-                  <a:srgbClr val="1F4E79"/>
-                </a:solidFill>
-                <a:latin typeface="Calibri"/>
-              </a:rPr>
-              <a:t>Szacowany nakład pracy</a:t>
-            </a:r>
-          </a:p>
-        </p:txBody>
-      </p:sp>
-      <p:sp>
-        <p:nvSpPr>
-          <p:cNvPr id="23" name="TextBox 22"/>
-          <p:cNvSpPr txBox="1"/>
-          <p:nvPr/>
-        </p:nvSpPr>
-        <p:spPr>
-          <a:xfrm>
-            <a:off x="6983999" y="2592000"/>
-            <a:ext cx="4488119" cy="288000"/>
-          </a:xfrm>
-          <a:prstGeom prst="rect">
-            <a:avLst/>
-          </a:prstGeom>
-          <a:noFill/>
-        </p:spPr>
-        <p:txBody>
-          <a:bodyPr wrap="square" lIns="0" rIns="0" tIns="0" bIns="0">
-            <a:spAutoFit/>
-          </a:bodyPr>
-          <a:lstStyle/>
-          <a:p>
-            <a:pPr algn="l"/>
-            <a:r>
-              <a:rPr sz="1100" b="0" i="1">
-                <a:solidFill>
-                  <a:srgbClr val="555555"/>
-                </a:solidFill>
-                <a:latin typeface="Calibri"/>
-              </a:rPr>
-              <a:t>(blended: dev + QA + PM + design + DevOps)</a:t>
-            </a:r>
-          </a:p>
-        </p:txBody>
-      </p:sp>
-      <p:sp>
-        <p:nvSpPr>
-          <p:cNvPr id="24" name="TextBox 23"/>
-          <p:cNvSpPr txBox="1"/>
-          <p:nvPr/>
-        </p:nvSpPr>
-        <p:spPr>
-          <a:xfrm>
-            <a:off x="6983999" y="3060000"/>
-            <a:ext cx="3300119" cy="288000"/>
-          </a:xfrm>
-          <a:prstGeom prst="rect">
-            <a:avLst/>
-          </a:prstGeom>
-          <a:noFill/>
-        </p:spPr>
-        <p:txBody>
-          <a:bodyPr wrap="square" lIns="0" rIns="0" tIns="0" bIns="0">
-            <a:spAutoFit/>
-          </a:bodyPr>
-          <a:lstStyle/>
-          <a:p>
-            <a:pPr algn="l"/>
-            <a:r>
-              <a:rPr sz="1200" b="0" i="0">
-                <a:solidFill>
-                  <a:srgbClr val="1A1A1A"/>
-                </a:solidFill>
-                <a:latin typeface="Calibri"/>
-              </a:rPr>
-              <a:t>Backend</a:t>
-            </a:r>
-          </a:p>
-        </p:txBody>
-      </p:sp>
-      <p:sp>
-        <p:nvSpPr>
-          <p:cNvPr id="25" name="TextBox 24"/>
-          <p:cNvSpPr txBox="1"/>
-          <p:nvPr/>
-        </p:nvSpPr>
-        <p:spPr>
-          <a:xfrm>
-            <a:off x="10032119" y="3060000"/>
-            <a:ext cx="1368000" cy="288000"/>
-          </a:xfrm>
-          <a:prstGeom prst="rect">
-            <a:avLst/>
-          </a:prstGeom>
-          <a:noFill/>
-        </p:spPr>
-        <p:txBody>
-          <a:bodyPr wrap="square" lIns="0" rIns="0" tIns="0" bIns="0">
-            <a:spAutoFit/>
-          </a:bodyPr>
-          <a:lstStyle/>
-          <a:p>
-            <a:pPr algn="r"/>
-            <a:r>
-              <a:rPr sz="1200" b="1" i="0">
-                <a:solidFill>
-                  <a:srgbClr val="1F4E79"/>
-                </a:solidFill>
-                <a:latin typeface="Calibri"/>
-              </a:rPr>
-              <a:t>≈ 45 dni</a:t>
-            </a:r>
-          </a:p>
-        </p:txBody>
-      </p:sp>
-      <p:sp>
-        <p:nvSpPr>
-          <p:cNvPr id="26" name="TextBox 25"/>
-          <p:cNvSpPr txBox="1"/>
-          <p:nvPr/>
-        </p:nvSpPr>
-        <p:spPr>
-          <a:xfrm>
-            <a:off x="6983999" y="3420000"/>
-            <a:ext cx="3300119" cy="288000"/>
-          </a:xfrm>
-          <a:prstGeom prst="rect">
-            <a:avLst/>
-          </a:prstGeom>
-          <a:noFill/>
-        </p:spPr>
-        <p:txBody>
-          <a:bodyPr wrap="square" lIns="0" rIns="0" tIns="0" bIns="0">
-            <a:spAutoFit/>
-          </a:bodyPr>
-          <a:lstStyle/>
-          <a:p>
-            <a:pPr algn="l"/>
-            <a:r>
-              <a:rPr sz="1200" b="0" i="0">
-                <a:solidFill>
-                  <a:srgbClr val="1A1A1A"/>
-                </a:solidFill>
-                <a:latin typeface="Calibri"/>
-              </a:rPr>
-              <a:t>Frontend</a:t>
-            </a:r>
-          </a:p>
-        </p:txBody>
-      </p:sp>
-      <p:sp>
-        <p:nvSpPr>
-          <p:cNvPr id="27" name="TextBox 26"/>
-          <p:cNvSpPr txBox="1"/>
-          <p:nvPr/>
-        </p:nvSpPr>
-        <p:spPr>
-          <a:xfrm>
-            <a:off x="10032119" y="3420000"/>
-            <a:ext cx="1368000" cy="288000"/>
-          </a:xfrm>
-          <a:prstGeom prst="rect">
-            <a:avLst/>
-          </a:prstGeom>
-          <a:noFill/>
-        </p:spPr>
-        <p:txBody>
-          <a:bodyPr wrap="square" lIns="0" rIns="0" tIns="0" bIns="0">
-            <a:spAutoFit/>
-          </a:bodyPr>
-          <a:lstStyle/>
-          <a:p>
-            <a:pPr algn="r"/>
-            <a:r>
-              <a:rPr sz="1200" b="1" i="0">
-                <a:solidFill>
-                  <a:srgbClr val="1F4E79"/>
-                </a:solidFill>
-                <a:latin typeface="Calibri"/>
-              </a:rPr>
-              <a:t>≈ 55 dni</a:t>
-            </a:r>
-          </a:p>
-        </p:txBody>
-      </p:sp>
-      <p:sp>
-        <p:nvSpPr>
-          <p:cNvPr id="28" name="TextBox 27"/>
-          <p:cNvSpPr txBox="1"/>
-          <p:nvPr/>
-        </p:nvSpPr>
-        <p:spPr>
-          <a:xfrm>
-            <a:off x="6983999" y="3780000"/>
-            <a:ext cx="3300119" cy="288000"/>
-          </a:xfrm>
-          <a:prstGeom prst="rect">
-            <a:avLst/>
-          </a:prstGeom>
-          <a:noFill/>
-        </p:spPr>
-        <p:txBody>
-          <a:bodyPr wrap="square" lIns="0" rIns="0" tIns="0" bIns="0">
-            <a:spAutoFit/>
-          </a:bodyPr>
-          <a:lstStyle/>
-          <a:p>
-            <a:pPr algn="l"/>
-            <a:r>
-              <a:rPr sz="1200" b="0" i="0">
-                <a:solidFill>
-                  <a:srgbClr val="1A1A1A"/>
-                </a:solidFill>
-                <a:latin typeface="Calibri"/>
-              </a:rPr>
-              <a:t>Design, PM, QA, CI, dokumentacja</a:t>
-            </a:r>
-          </a:p>
-        </p:txBody>
-      </p:sp>
-      <p:sp>
-        <p:nvSpPr>
-          <p:cNvPr id="29" name="TextBox 28"/>
-          <p:cNvSpPr txBox="1"/>
-          <p:nvPr/>
-        </p:nvSpPr>
-        <p:spPr>
-          <a:xfrm>
-            <a:off x="10032119" y="3780000"/>
-            <a:ext cx="1368000" cy="288000"/>
-          </a:xfrm>
-          <a:prstGeom prst="rect">
-            <a:avLst/>
-          </a:prstGeom>
-          <a:noFill/>
-        </p:spPr>
-        <p:txBody>
-          <a:bodyPr wrap="square" lIns="0" rIns="0" tIns="0" bIns="0">
-            <a:spAutoFit/>
-          </a:bodyPr>
-          <a:lstStyle/>
-          <a:p>
-            <a:pPr algn="r"/>
-            <a:r>
-              <a:rPr sz="1200" b="1" i="0">
-                <a:solidFill>
-                  <a:srgbClr val="1F4E79"/>
-                </a:solidFill>
-                <a:latin typeface="Calibri"/>
-              </a:rPr>
-              <a:t>≈ 25 dni</a:t>
-            </a:r>
-          </a:p>
-        </p:txBody>
-      </p:sp>
-      <p:sp>
-        <p:nvSpPr>
-          <p:cNvPr id="30" name="Rectangle 29"/>
-          <p:cNvSpPr/>
-          <p:nvPr/>
-        </p:nvSpPr>
-        <p:spPr>
-          <a:xfrm>
-            <a:off x="6983999" y="4284000"/>
-            <a:ext cx="4416120" cy="18000"/>
-          </a:xfrm>
-          <a:prstGeom prst="rect">
-            <a:avLst/>
-          </a:prstGeom>
-          <a:solidFill>
-            <a:srgbClr val="E8B44F"/>
-          </a:solidFill>
-          <a:ln>
-            <a:noFill/>
-          </a:ln>
-          <a:effectLst/>
-        </p:spPr>
-        <p:style>
-          <a:lnRef idx="1">
-            <a:schemeClr val="accent1"/>
-          </a:lnRef>
-          <a:fillRef idx="3">
-            <a:schemeClr val="accent1"/>
-          </a:fillRef>
-          <a:effectRef idx="2">
-            <a:schemeClr val="accent1"/>
-          </a:effectRef>
-          <a:fontRef idx="minor">
-            <a:schemeClr val="lt1"/>
-          </a:fontRef>
-        </p:style>
-        <p:txBody>
-          <a:bodyPr rtlCol="0" anchor="ctr"/>
-          <a:lstStyle/>
-          <a:p>
-            <a:pPr algn="ctr"/>
-          </a:p>
-        </p:txBody>
-      </p:sp>
-      <p:sp>
-        <p:nvSpPr>
-          <p:cNvPr id="31" name="TextBox 30"/>
-          <p:cNvSpPr txBox="1"/>
-          <p:nvPr/>
-        </p:nvSpPr>
-        <p:spPr>
-          <a:xfrm>
-            <a:off x="6983999" y="4428000"/>
-            <a:ext cx="3300119" cy="288000"/>
-          </a:xfrm>
-          <a:prstGeom prst="rect">
-            <a:avLst/>
-          </a:prstGeom>
-          <a:noFill/>
-        </p:spPr>
-        <p:txBody>
-          <a:bodyPr wrap="square" lIns="0" rIns="0" tIns="0" bIns="0">
-            <a:spAutoFit/>
-          </a:bodyPr>
-          <a:lstStyle/>
-          <a:p>
-            <a:pPr algn="l"/>
-            <a:r>
-              <a:rPr sz="1400" b="1" i="0">
-                <a:solidFill>
-                  <a:srgbClr val="1A1A1A"/>
-                </a:solidFill>
-                <a:latin typeface="Calibri"/>
-              </a:rPr>
-              <a:t>Razem</a:t>
-            </a:r>
-          </a:p>
-        </p:txBody>
-      </p:sp>
-      <p:sp>
-        <p:nvSpPr>
-          <p:cNvPr id="32" name="TextBox 31"/>
-          <p:cNvSpPr txBox="1"/>
-          <p:nvPr/>
-        </p:nvSpPr>
-        <p:spPr>
-          <a:xfrm>
-            <a:off x="10032119" y="4428000"/>
-            <a:ext cx="1368000" cy="288000"/>
-          </a:xfrm>
-          <a:prstGeom prst="rect">
-            <a:avLst/>
-          </a:prstGeom>
-          <a:noFill/>
-        </p:spPr>
-        <p:txBody>
-          <a:bodyPr wrap="square" lIns="0" rIns="0" tIns="0" bIns="0">
-            <a:spAutoFit/>
-          </a:bodyPr>
-          <a:lstStyle/>
-          <a:p>
-            <a:pPr algn="r"/>
-            <a:r>
-              <a:rPr sz="1400" b="1" i="0">
-                <a:solidFill>
-                  <a:srgbClr val="2F9E44"/>
-                </a:solidFill>
-                <a:latin typeface="Calibri"/>
-              </a:rPr>
-              <a:t>≈ 120–130 osobodni</a:t>
-            </a:r>
-          </a:p>
-        </p:txBody>
-      </p:sp>
-      <p:sp>
-        <p:nvSpPr>
-          <p:cNvPr id="33" name="TextBox 32"/>
-          <p:cNvSpPr txBox="1"/>
-          <p:nvPr/>
-        </p:nvSpPr>
-        <p:spPr>
-          <a:xfrm>
-            <a:off x="6983999" y="4860000"/>
-            <a:ext cx="4416120" cy="540000"/>
-          </a:xfrm>
-          <a:prstGeom prst="rect">
-            <a:avLst/>
-          </a:prstGeom>
-          <a:noFill/>
-        </p:spPr>
-        <p:txBody>
-          <a:bodyPr wrap="square" lIns="0" rIns="0" tIns="0" bIns="0">
-            <a:spAutoFit/>
-          </a:bodyPr>
-          <a:lstStyle/>
-          <a:p>
-            <a:pPr algn="l"/>
-            <a:r>
-              <a:rPr sz="1000" b="0" i="1">
-                <a:solidFill>
-                  <a:srgbClr val="555555"/>
-                </a:solidFill>
-                <a:latin typeface="Calibri"/>
-              </a:rPr>
-              <a:t>czyli około 6 człowiekomiesięcy. Realny projekt od zera kosztuje zwykle 20–40% więcej (discovery, rework, spotkania).</a:t>
-            </a:r>
-          </a:p>
-        </p:txBody>
-      </p:sp>
-    </p:spTree>
-  </p:cSld>
-  <p:clrMapOvr>
-    <a:masterClrMapping/>
-  </p:clrMapOvr>
-</p:sld>
-</file>
-
-<file path=ppt/slides/slide21.xml><?xml version="1.0" encoding="utf-8"?>
-<p:sld xmlns:a="http://schemas.openxmlformats.org/drawingml/2006/main" xmlns:p="http://schemas.openxmlformats.org/presentationml/2006/main" xmlns:r="http://schemas.openxmlformats.org/officeDocument/2006/relationships">
-  <p:cSld>
-    <p:bg>
-      <p:bgPr>
-        <a:solidFill>
-          <a:srgbClr val="FFFFFF"/>
-        </a:solidFill>
-        <a:effectLst/>
-      </p:bgPr>
-    </p:bg>
-    <p:spTree>
-      <p:nvGrpSpPr>
-        <p:cNvPr id="1" name=""/>
-        <p:cNvGrpSpPr/>
-        <p:nvPr/>
-      </p:nvGrpSpPr>
-      <p:grpSpPr/>
-      <p:sp>
-        <p:nvSpPr>
-          <p:cNvPr id="2" name="Rectangle 1"/>
-          <p:cNvSpPr/>
-          <p:nvPr/>
-        </p:nvSpPr>
-        <p:spPr>
-          <a:xfrm>
-            <a:off x="0" y="0"/>
-            <a:ext cx="12192119" cy="720000"/>
-          </a:xfrm>
-          <a:prstGeom prst="rect">
-            <a:avLst/>
-          </a:prstGeom>
-          <a:solidFill>
-            <a:srgbClr val="1F4E79"/>
-          </a:solidFill>
-          <a:ln>
-            <a:noFill/>
-          </a:ln>
-          <a:effectLst/>
-        </p:spPr>
-        <p:style>
-          <a:lnRef idx="1">
-            <a:schemeClr val="accent1"/>
-          </a:lnRef>
-          <a:fillRef idx="3">
-            <a:schemeClr val="accent1"/>
-          </a:fillRef>
-          <a:effectRef idx="2">
-            <a:schemeClr val="accent1"/>
-          </a:effectRef>
-          <a:fontRef idx="minor">
-            <a:schemeClr val="lt1"/>
-          </a:fontRef>
-        </p:style>
-        <p:txBody>
-          <a:bodyPr rtlCol="0" anchor="ctr"/>
-          <a:lstStyle/>
-          <a:p>
-            <a:pPr algn="ctr"/>
-          </a:p>
-        </p:txBody>
-      </p:sp>
-      <p:sp>
-        <p:nvSpPr>
-          <p:cNvPr id="3" name="Rectangle 2"/>
-          <p:cNvSpPr/>
-          <p:nvPr/>
-        </p:nvSpPr>
-        <p:spPr>
-          <a:xfrm>
-            <a:off x="0" y="720000"/>
-            <a:ext cx="12192119" cy="36000"/>
-          </a:xfrm>
-          <a:prstGeom prst="rect">
-            <a:avLst/>
-          </a:prstGeom>
-          <a:solidFill>
-            <a:srgbClr val="E8B44F"/>
-          </a:solidFill>
-          <a:ln>
-            <a:noFill/>
-          </a:ln>
-          <a:effectLst/>
-        </p:spPr>
-        <p:style>
-          <a:lnRef idx="1">
-            <a:schemeClr val="accent1"/>
-          </a:lnRef>
-          <a:fillRef idx="3">
-            <a:schemeClr val="accent1"/>
-          </a:fillRef>
-          <a:effectRef idx="2">
-            <a:schemeClr val="accent1"/>
-          </a:effectRef>
-          <a:fontRef idx="minor">
-            <a:schemeClr val="lt1"/>
-          </a:fontRef>
-        </p:style>
-        <p:txBody>
-          <a:bodyPr rtlCol="0" anchor="ctr"/>
-          <a:lstStyle/>
-          <a:p>
-            <a:pPr algn="ctr"/>
-          </a:p>
-        </p:txBody>
-      </p:sp>
-      <p:sp>
-        <p:nvSpPr>
-          <p:cNvPr id="4" name="TextBox 3"/>
-          <p:cNvSpPr txBox="1"/>
-          <p:nvPr/>
-        </p:nvSpPr>
-        <p:spPr>
-          <a:xfrm>
-            <a:off x="360000" y="198000"/>
-            <a:ext cx="11472119" cy="432000"/>
-          </a:xfrm>
-          <a:prstGeom prst="rect">
-            <a:avLst/>
-          </a:prstGeom>
-          <a:noFill/>
-        </p:spPr>
-        <p:txBody>
-          <a:bodyPr wrap="square" lIns="0" rIns="0" tIns="0" bIns="0">
-            <a:spAutoFit/>
-          </a:bodyPr>
-          <a:lstStyle/>
-          <a:p>
-            <a:pPr algn="l"/>
-            <a:r>
-              <a:rPr sz="2400" b="1" i="0">
-                <a:solidFill>
-                  <a:srgbClr val="FFFFFF"/>
-                </a:solidFill>
-                <a:latin typeface="Calibri"/>
-              </a:rPr>
-              <a:t>Wycena projektu — cena dla klienta</a:t>
-            </a:r>
-          </a:p>
-        </p:txBody>
-      </p:sp>
-      <p:sp>
-        <p:nvSpPr>
-          <p:cNvPr id="5" name="TextBox 4"/>
-          <p:cNvSpPr txBox="1"/>
-          <p:nvPr/>
-        </p:nvSpPr>
-        <p:spPr>
-          <a:xfrm>
-            <a:off x="11112119" y="270000"/>
-            <a:ext cx="900000" cy="216000"/>
-          </a:xfrm>
-          <a:prstGeom prst="rect">
-            <a:avLst/>
-          </a:prstGeom>
-          <a:noFill/>
-        </p:spPr>
-        <p:txBody>
-          <a:bodyPr wrap="square" lIns="0" rIns="0" tIns="0" bIns="0">
-            <a:spAutoFit/>
-          </a:bodyPr>
-          <a:lstStyle/>
-          <a:p>
-            <a:pPr algn="r"/>
-            <a:r>
-              <a:rPr sz="1000" b="0" i="0">
-                <a:solidFill>
-                  <a:srgbClr val="E8F0F9"/>
-                </a:solidFill>
-                <a:latin typeface="Calibri"/>
-              </a:rPr>
-              <a:t>21 / 21</a:t>
-            </a:r>
-          </a:p>
-        </p:txBody>
-      </p:sp>
-      <p:sp>
-        <p:nvSpPr>
-          <p:cNvPr id="6" name="TextBox 5"/>
-          <p:cNvSpPr txBox="1"/>
-          <p:nvPr/>
-        </p:nvSpPr>
-        <p:spPr>
-          <a:xfrm>
-            <a:off x="540000" y="1007999"/>
-            <a:ext cx="11112119" cy="360000"/>
-          </a:xfrm>
-          <a:prstGeom prst="rect">
-            <a:avLst/>
-          </a:prstGeom>
-          <a:noFill/>
-        </p:spPr>
-        <p:txBody>
-          <a:bodyPr wrap="square" lIns="0" rIns="0" tIns="0" bIns="0">
-            <a:spAutoFit/>
-          </a:bodyPr>
-          <a:lstStyle/>
-          <a:p>
-            <a:pPr algn="l"/>
-            <a:r>
-              <a:rPr sz="1600" b="1" i="0">
-                <a:solidFill>
-                  <a:srgbClr val="1F4E79"/>
-                </a:solidFill>
-                <a:latin typeface="Calibri"/>
-              </a:rPr>
-              <a:t>Cena w zależności od rynku (USD)</a:t>
-            </a:r>
-          </a:p>
-        </p:txBody>
-      </p:sp>
-      <p:sp>
-        <p:nvSpPr>
-          <p:cNvPr id="7" name="Rectangle 6"/>
-          <p:cNvSpPr/>
-          <p:nvPr/>
-        </p:nvSpPr>
-        <p:spPr>
-          <a:xfrm>
-            <a:off x="540000" y="1440000"/>
-            <a:ext cx="11112119" cy="360000"/>
-          </a:xfrm>
-          <a:prstGeom prst="rect">
-            <a:avLst/>
-          </a:prstGeom>
-          <a:solidFill>
-            <a:srgbClr val="1F4E79"/>
-          </a:solidFill>
-          <a:ln>
-            <a:noFill/>
-          </a:ln>
-          <a:effectLst/>
-        </p:spPr>
-        <p:style>
-          <a:lnRef idx="1">
-            <a:schemeClr val="accent1"/>
-          </a:lnRef>
-          <a:fillRef idx="3">
-            <a:schemeClr val="accent1"/>
-          </a:fillRef>
-          <a:effectRef idx="2">
-            <a:schemeClr val="accent1"/>
-          </a:effectRef>
-          <a:fontRef idx="minor">
-            <a:schemeClr val="lt1"/>
-          </a:fontRef>
-        </p:style>
-        <p:txBody>
-          <a:bodyPr rtlCol="0" anchor="ctr"/>
-          <a:lstStyle/>
-          <a:p>
-            <a:pPr algn="ctr"/>
-          </a:p>
-        </p:txBody>
-      </p:sp>
-      <p:sp>
-        <p:nvSpPr>
-          <p:cNvPr id="8" name="TextBox 7"/>
-          <p:cNvSpPr txBox="1"/>
-          <p:nvPr/>
-        </p:nvSpPr>
-        <p:spPr>
-          <a:xfrm>
-            <a:off x="648000" y="1512000"/>
-            <a:ext cx="4464000" cy="251999"/>
-          </a:xfrm>
-          <a:prstGeom prst="rect">
-            <a:avLst/>
-          </a:prstGeom>
-          <a:noFill/>
-        </p:spPr>
-        <p:txBody>
-          <a:bodyPr wrap="square" lIns="0" rIns="0" tIns="0" bIns="0">
-            <a:spAutoFit/>
-          </a:bodyPr>
-          <a:lstStyle/>
-          <a:p>
-            <a:pPr algn="l"/>
-            <a:r>
-              <a:rPr sz="1300" b="1" i="0">
-                <a:solidFill>
-                  <a:srgbClr val="FFFFFF"/>
-                </a:solidFill>
-                <a:latin typeface="Calibri"/>
-              </a:rPr>
-              <a:t>Scenariusz</a:t>
-            </a:r>
-          </a:p>
-        </p:txBody>
-      </p:sp>
-      <p:sp>
-        <p:nvSpPr>
-          <p:cNvPr id="9" name="TextBox 8"/>
-          <p:cNvSpPr txBox="1"/>
-          <p:nvPr/>
-        </p:nvSpPr>
-        <p:spPr>
-          <a:xfrm>
-            <a:off x="5508000" y="1512000"/>
-            <a:ext cx="3204000" cy="251999"/>
-          </a:xfrm>
-          <a:prstGeom prst="rect">
-            <a:avLst/>
-          </a:prstGeom>
-          <a:noFill/>
-        </p:spPr>
-        <p:txBody>
-          <a:bodyPr wrap="square" lIns="0" rIns="0" tIns="0" bIns="0">
-            <a:spAutoFit/>
-          </a:bodyPr>
-          <a:lstStyle/>
-          <a:p>
-            <a:pPr algn="l"/>
-            <a:r>
-              <a:rPr sz="1300" b="1" i="0">
-                <a:solidFill>
-                  <a:srgbClr val="FFFFFF"/>
-                </a:solidFill>
-                <a:latin typeface="Calibri"/>
-              </a:rPr>
-              <a:t>Stawka dzienna</a:t>
-            </a:r>
-          </a:p>
-        </p:txBody>
-      </p:sp>
-      <p:sp>
-        <p:nvSpPr>
-          <p:cNvPr id="10" name="TextBox 9"/>
-          <p:cNvSpPr txBox="1"/>
-          <p:nvPr/>
-        </p:nvSpPr>
-        <p:spPr>
-          <a:xfrm>
-            <a:off x="9108000" y="1512000"/>
-            <a:ext cx="2484000" cy="251999"/>
-          </a:xfrm>
-          <a:prstGeom prst="rect">
-            <a:avLst/>
-          </a:prstGeom>
-          <a:noFill/>
-        </p:spPr>
-        <p:txBody>
-          <a:bodyPr wrap="square" lIns="0" rIns="0" tIns="0" bIns="0">
-            <a:spAutoFit/>
-          </a:bodyPr>
-          <a:lstStyle/>
-          <a:p>
-            <a:pPr algn="l"/>
-            <a:r>
-              <a:rPr sz="1300" b="1" i="0">
-                <a:solidFill>
-                  <a:srgbClr val="FFFFFF"/>
-                </a:solidFill>
-                <a:latin typeface="Calibri"/>
-              </a:rPr>
-              <a:t>Wycena projektu</a:t>
-            </a:r>
-          </a:p>
-        </p:txBody>
-      </p:sp>
-      <p:sp>
-        <p:nvSpPr>
-          <p:cNvPr id="11" name="Rectangle 10"/>
-          <p:cNvSpPr/>
-          <p:nvPr/>
-        </p:nvSpPr>
-        <p:spPr>
-          <a:xfrm>
-            <a:off x="540000" y="1800000"/>
-            <a:ext cx="11112119" cy="540000"/>
-          </a:xfrm>
-          <a:prstGeom prst="rect">
-            <a:avLst/>
-          </a:prstGeom>
-          <a:solidFill>
-            <a:srgbClr val="FFFFFF"/>
-          </a:solidFill>
-          <a:ln>
-            <a:noFill/>
-          </a:ln>
-          <a:effectLst/>
-        </p:spPr>
-        <p:style>
-          <a:lnRef idx="1">
-            <a:schemeClr val="accent1"/>
-          </a:lnRef>
-          <a:fillRef idx="3">
-            <a:schemeClr val="accent1"/>
-          </a:fillRef>
-          <a:effectRef idx="2">
-            <a:schemeClr val="accent1"/>
-          </a:effectRef>
-          <a:fontRef idx="minor">
-            <a:schemeClr val="lt1"/>
-          </a:fontRef>
-        </p:style>
-        <p:txBody>
-          <a:bodyPr rtlCol="0" anchor="ctr"/>
-          <a:lstStyle/>
-          <a:p>
-            <a:pPr algn="ctr"/>
-          </a:p>
-        </p:txBody>
-      </p:sp>
-      <p:sp>
-        <p:nvSpPr>
-          <p:cNvPr id="12" name="TextBox 11"/>
-          <p:cNvSpPr txBox="1"/>
-          <p:nvPr/>
-        </p:nvSpPr>
-        <p:spPr>
-          <a:xfrm>
-            <a:off x="648000" y="1944000"/>
-            <a:ext cx="4464000" cy="288000"/>
-          </a:xfrm>
-          <a:prstGeom prst="rect">
-            <a:avLst/>
-          </a:prstGeom>
-          <a:noFill/>
-        </p:spPr>
-        <p:txBody>
-          <a:bodyPr wrap="square" lIns="0" rIns="0" tIns="0" bIns="0">
-            <a:spAutoFit/>
-          </a:bodyPr>
-          <a:lstStyle/>
-          <a:p>
-            <a:pPr algn="l"/>
-            <a:r>
-              <a:rPr sz="1200" b="0" i="0">
-                <a:solidFill>
-                  <a:srgbClr val="1A1A1A"/>
-                </a:solidFill>
-                <a:latin typeface="Calibri"/>
-              </a:rPr>
-              <a:t>Freelancer / offshore (Azja, junior PL)</a:t>
-            </a:r>
-          </a:p>
-        </p:txBody>
-      </p:sp>
-      <p:sp>
-        <p:nvSpPr>
-          <p:cNvPr id="13" name="TextBox 12"/>
-          <p:cNvSpPr txBox="1"/>
-          <p:nvPr/>
-        </p:nvSpPr>
-        <p:spPr>
-          <a:xfrm>
-            <a:off x="5508000" y="1944000"/>
-            <a:ext cx="3204000" cy="288000"/>
-          </a:xfrm>
-          <a:prstGeom prst="rect">
-            <a:avLst/>
-          </a:prstGeom>
-          <a:noFill/>
-        </p:spPr>
-        <p:txBody>
-          <a:bodyPr wrap="square" lIns="0" rIns="0" tIns="0" bIns="0">
-            <a:spAutoFit/>
-          </a:bodyPr>
-          <a:lstStyle/>
-          <a:p>
-            <a:pPr algn="l"/>
-            <a:r>
-              <a:rPr sz="1200" b="0" i="0">
-                <a:solidFill>
-                  <a:srgbClr val="1A1A1A"/>
-                </a:solidFill>
-                <a:latin typeface="Calibri"/>
-              </a:rPr>
-              <a:t>~$250 – $350</a:t>
-            </a:r>
-          </a:p>
-        </p:txBody>
-      </p:sp>
-      <p:sp>
-        <p:nvSpPr>
-          <p:cNvPr id="14" name="TextBox 13"/>
-          <p:cNvSpPr txBox="1"/>
-          <p:nvPr/>
-        </p:nvSpPr>
-        <p:spPr>
-          <a:xfrm>
-            <a:off x="9108000" y="1944000"/>
-            <a:ext cx="2484000" cy="288000"/>
-          </a:xfrm>
-          <a:prstGeom prst="rect">
-            <a:avLst/>
-          </a:prstGeom>
-          <a:noFill/>
-        </p:spPr>
-        <p:txBody>
-          <a:bodyPr wrap="square" lIns="0" rIns="0" tIns="0" bIns="0">
-            <a:spAutoFit/>
-          </a:bodyPr>
-          <a:lstStyle/>
-          <a:p>
-            <a:pPr algn="l"/>
-            <a:r>
-              <a:rPr sz="1200" b="0" i="0">
-                <a:solidFill>
-                  <a:srgbClr val="1A1A1A"/>
-                </a:solidFill>
-                <a:latin typeface="Calibri"/>
-              </a:rPr>
-              <a:t>$30 000 – $45 000</a:t>
-            </a:r>
-          </a:p>
-        </p:txBody>
-      </p:sp>
-      <p:sp>
-        <p:nvSpPr>
-          <p:cNvPr id="15" name="Rectangle 14"/>
-          <p:cNvSpPr/>
-          <p:nvPr/>
-        </p:nvSpPr>
-        <p:spPr>
-          <a:xfrm>
-            <a:off x="540000" y="2340000"/>
-            <a:ext cx="11112119" cy="540000"/>
-          </a:xfrm>
-          <a:prstGeom prst="rect">
-            <a:avLst/>
-          </a:prstGeom>
-          <a:solidFill>
-            <a:srgbClr val="E8F0F9"/>
-          </a:solidFill>
-          <a:ln>
-            <a:noFill/>
-          </a:ln>
-          <a:effectLst/>
-        </p:spPr>
-        <p:style>
-          <a:lnRef idx="1">
-            <a:schemeClr val="accent1"/>
-          </a:lnRef>
-          <a:fillRef idx="3">
-            <a:schemeClr val="accent1"/>
-          </a:fillRef>
-          <a:effectRef idx="2">
-            <a:schemeClr val="accent1"/>
-          </a:effectRef>
-          <a:fontRef idx="minor">
-            <a:schemeClr val="lt1"/>
-          </a:fontRef>
-        </p:style>
-        <p:txBody>
-          <a:bodyPr rtlCol="0" anchor="ctr"/>
-          <a:lstStyle/>
-          <a:p>
-            <a:pPr algn="ctr"/>
-          </a:p>
-        </p:txBody>
-      </p:sp>
-      <p:sp>
-        <p:nvSpPr>
-          <p:cNvPr id="16" name="Rectangle 15"/>
-          <p:cNvSpPr/>
-          <p:nvPr/>
-        </p:nvSpPr>
-        <p:spPr>
-          <a:xfrm>
-            <a:off x="540000" y="2340000"/>
-            <a:ext cx="108000" cy="540000"/>
-          </a:xfrm>
-          <a:prstGeom prst="rect">
-            <a:avLst/>
-          </a:prstGeom>
-          <a:solidFill>
-            <a:srgbClr val="E8B44F"/>
-          </a:solidFill>
-          <a:ln>
-            <a:noFill/>
-          </a:ln>
-          <a:effectLst/>
-        </p:spPr>
-        <p:style>
-          <a:lnRef idx="1">
-            <a:schemeClr val="accent1"/>
-          </a:lnRef>
-          <a:fillRef idx="3">
-            <a:schemeClr val="accent1"/>
-          </a:fillRef>
-          <a:effectRef idx="2">
-            <a:schemeClr val="accent1"/>
-          </a:effectRef>
-          <a:fontRef idx="minor">
-            <a:schemeClr val="lt1"/>
-          </a:fontRef>
-        </p:style>
-        <p:txBody>
-          <a:bodyPr rtlCol="0" anchor="ctr"/>
-          <a:lstStyle/>
-          <a:p>
-            <a:pPr algn="ctr"/>
-          </a:p>
-        </p:txBody>
-      </p:sp>
-      <p:sp>
-        <p:nvSpPr>
-          <p:cNvPr id="17" name="TextBox 16"/>
-          <p:cNvSpPr txBox="1"/>
-          <p:nvPr/>
-        </p:nvSpPr>
-        <p:spPr>
-          <a:xfrm>
-            <a:off x="648000" y="2484000"/>
-            <a:ext cx="4464000" cy="288000"/>
-          </a:xfrm>
-          <a:prstGeom prst="rect">
-            <a:avLst/>
-          </a:prstGeom>
-          <a:noFill/>
-        </p:spPr>
-        <p:txBody>
-          <a:bodyPr wrap="square" lIns="0" rIns="0" tIns="0" bIns="0">
-            <a:spAutoFit/>
-          </a:bodyPr>
-          <a:lstStyle/>
-          <a:p>
-            <a:pPr algn="l"/>
-            <a:r>
-              <a:rPr sz="1200" b="1" i="0">
-                <a:solidFill>
-                  <a:srgbClr val="1A1A1A"/>
-                </a:solidFill>
-                <a:latin typeface="Calibri"/>
-              </a:rPr>
-              <a:t>Polski software house (typowy B2B)</a:t>
-            </a:r>
-          </a:p>
-        </p:txBody>
-      </p:sp>
-      <p:sp>
-        <p:nvSpPr>
-          <p:cNvPr id="18" name="TextBox 17"/>
-          <p:cNvSpPr txBox="1"/>
-          <p:nvPr/>
-        </p:nvSpPr>
-        <p:spPr>
-          <a:xfrm>
-            <a:off x="5508000" y="2484000"/>
-            <a:ext cx="3204000" cy="288000"/>
-          </a:xfrm>
-          <a:prstGeom prst="rect">
-            <a:avLst/>
-          </a:prstGeom>
-          <a:noFill/>
-        </p:spPr>
-        <p:txBody>
-          <a:bodyPr wrap="square" lIns="0" rIns="0" tIns="0" bIns="0">
-            <a:spAutoFit/>
-          </a:bodyPr>
-          <a:lstStyle/>
-          <a:p>
-            <a:pPr algn="l"/>
-            <a:r>
-              <a:rPr sz="1200" b="1" i="0">
-                <a:solidFill>
-                  <a:srgbClr val="1A1A1A"/>
-                </a:solidFill>
-                <a:latin typeface="Calibri"/>
-              </a:rPr>
-              <a:t>~$450 – $550</a:t>
-            </a:r>
-          </a:p>
-        </p:txBody>
-      </p:sp>
-      <p:sp>
-        <p:nvSpPr>
-          <p:cNvPr id="19" name="TextBox 18"/>
-          <p:cNvSpPr txBox="1"/>
-          <p:nvPr/>
-        </p:nvSpPr>
-        <p:spPr>
-          <a:xfrm>
-            <a:off x="9108000" y="2484000"/>
-            <a:ext cx="2484000" cy="288000"/>
-          </a:xfrm>
-          <a:prstGeom prst="rect">
-            <a:avLst/>
-          </a:prstGeom>
-          <a:noFill/>
-        </p:spPr>
-        <p:txBody>
-          <a:bodyPr wrap="square" lIns="0" rIns="0" tIns="0" bIns="0">
-            <a:spAutoFit/>
-          </a:bodyPr>
-          <a:lstStyle/>
-          <a:p>
-            <a:pPr algn="l"/>
-            <a:r>
-              <a:rPr sz="1200" b="1" i="0">
-                <a:solidFill>
-                  <a:srgbClr val="1A1A1A"/>
-                </a:solidFill>
-                <a:latin typeface="Calibri"/>
-              </a:rPr>
-              <a:t>$55 000 – $75 000</a:t>
-            </a:r>
-          </a:p>
-        </p:txBody>
-      </p:sp>
-      <p:sp>
-        <p:nvSpPr>
-          <p:cNvPr id="20" name="Rectangle 19"/>
-          <p:cNvSpPr/>
-          <p:nvPr/>
-        </p:nvSpPr>
-        <p:spPr>
-          <a:xfrm>
-            <a:off x="540000" y="2880000"/>
-            <a:ext cx="11112119" cy="540000"/>
-          </a:xfrm>
-          <a:prstGeom prst="rect">
-            <a:avLst/>
-          </a:prstGeom>
-          <a:solidFill>
-            <a:srgbClr val="FFFFFF"/>
-          </a:solidFill>
-          <a:ln>
-            <a:noFill/>
-          </a:ln>
-          <a:effectLst/>
-        </p:spPr>
-        <p:style>
-          <a:lnRef idx="1">
-            <a:schemeClr val="accent1"/>
-          </a:lnRef>
-          <a:fillRef idx="3">
-            <a:schemeClr val="accent1"/>
-          </a:fillRef>
-          <a:effectRef idx="2">
-            <a:schemeClr val="accent1"/>
-          </a:effectRef>
-          <a:fontRef idx="minor">
-            <a:schemeClr val="lt1"/>
-          </a:fontRef>
-        </p:style>
-        <p:txBody>
-          <a:bodyPr rtlCol="0" anchor="ctr"/>
-          <a:lstStyle/>
-          <a:p>
-            <a:pPr algn="ctr"/>
-          </a:p>
-        </p:txBody>
-      </p:sp>
-      <p:sp>
-        <p:nvSpPr>
-          <p:cNvPr id="21" name="TextBox 20"/>
-          <p:cNvSpPr txBox="1"/>
-          <p:nvPr/>
-        </p:nvSpPr>
-        <p:spPr>
-          <a:xfrm>
-            <a:off x="648000" y="3024000"/>
-            <a:ext cx="4464000" cy="288000"/>
-          </a:xfrm>
-          <a:prstGeom prst="rect">
-            <a:avLst/>
-          </a:prstGeom>
-          <a:noFill/>
-        </p:spPr>
-        <p:txBody>
-          <a:bodyPr wrap="square" lIns="0" rIns="0" tIns="0" bIns="0">
-            <a:spAutoFit/>
-          </a:bodyPr>
-          <a:lstStyle/>
-          <a:p>
-            <a:pPr algn="l"/>
-            <a:r>
-              <a:rPr sz="1200" b="0" i="0">
-                <a:solidFill>
-                  <a:srgbClr val="1A1A1A"/>
-                </a:solidFill>
-                <a:latin typeface="Calibri"/>
-              </a:rPr>
-              <a:t>Agencja Europa Zachodnia / US</a:t>
-            </a:r>
-          </a:p>
-        </p:txBody>
-      </p:sp>
-      <p:sp>
-        <p:nvSpPr>
-          <p:cNvPr id="22" name="TextBox 21"/>
-          <p:cNvSpPr txBox="1"/>
-          <p:nvPr/>
-        </p:nvSpPr>
-        <p:spPr>
-          <a:xfrm>
-            <a:off x="5508000" y="3024000"/>
-            <a:ext cx="3204000" cy="288000"/>
-          </a:xfrm>
-          <a:prstGeom prst="rect">
-            <a:avLst/>
-          </a:prstGeom>
-          <a:noFill/>
-        </p:spPr>
-        <p:txBody>
-          <a:bodyPr wrap="square" lIns="0" rIns="0" tIns="0" bIns="0">
-            <a:spAutoFit/>
-          </a:bodyPr>
-          <a:lstStyle/>
-          <a:p>
-            <a:pPr algn="l"/>
-            <a:r>
-              <a:rPr sz="1200" b="0" i="0">
-                <a:solidFill>
-                  <a:srgbClr val="1A1A1A"/>
-                </a:solidFill>
-                <a:latin typeface="Calibri"/>
-              </a:rPr>
-              <a:t>~$1 100 – $1 400</a:t>
-            </a:r>
-          </a:p>
-        </p:txBody>
-      </p:sp>
-      <p:sp>
-        <p:nvSpPr>
-          <p:cNvPr id="23" name="TextBox 22"/>
-          <p:cNvSpPr txBox="1"/>
-          <p:nvPr/>
-        </p:nvSpPr>
-        <p:spPr>
-          <a:xfrm>
-            <a:off x="9108000" y="3024000"/>
-            <a:ext cx="2484000" cy="288000"/>
-          </a:xfrm>
-          <a:prstGeom prst="rect">
-            <a:avLst/>
-          </a:prstGeom>
-          <a:noFill/>
-        </p:spPr>
-        <p:txBody>
-          <a:bodyPr wrap="square" lIns="0" rIns="0" tIns="0" bIns="0">
-            <a:spAutoFit/>
-          </a:bodyPr>
-          <a:lstStyle/>
-          <a:p>
-            <a:pPr algn="l"/>
-            <a:r>
-              <a:rPr sz="1200" b="0" i="0">
-                <a:solidFill>
-                  <a:srgbClr val="1A1A1A"/>
-                </a:solidFill>
-                <a:latin typeface="Calibri"/>
-              </a:rPr>
-              <a:t>$140 000 – $250 000</a:t>
-            </a:r>
-          </a:p>
-        </p:txBody>
-      </p:sp>
-      <p:sp>
-        <p:nvSpPr>
-          <p:cNvPr id="24" name="Rounded Rectangle 23"/>
-          <p:cNvSpPr/>
-          <p:nvPr/>
-        </p:nvSpPr>
-        <p:spPr>
-          <a:xfrm>
-            <a:off x="540000" y="4140000"/>
-            <a:ext cx="11112119" cy="1980000"/>
-          </a:xfrm>
-          <a:prstGeom prst="roundRect">
-            <a:avLst/>
-          </a:prstGeom>
-          <a:solidFill>
-            <a:srgbClr val="E8F0F9"/>
-          </a:solidFill>
-          <a:ln>
-            <a:noFill/>
-          </a:ln>
-          <a:effectLst/>
-        </p:spPr>
-        <p:style>
-          <a:lnRef idx="1">
-            <a:schemeClr val="accent1"/>
-          </a:lnRef>
-          <a:fillRef idx="3">
-            <a:schemeClr val="accent1"/>
-          </a:fillRef>
-          <a:effectRef idx="2">
-            <a:schemeClr val="accent1"/>
-          </a:effectRef>
-          <a:fontRef idx="minor">
-            <a:schemeClr val="lt1"/>
-          </a:fontRef>
-        </p:style>
-        <p:txBody>
-          <a:bodyPr rtlCol="0" anchor="ctr"/>
-          <a:lstStyle/>
-          <a:p>
-            <a:pPr algn="ctr"/>
-          </a:p>
-        </p:txBody>
-      </p:sp>
-      <p:sp>
-        <p:nvSpPr>
-          <p:cNvPr id="25" name="Rectangle 24"/>
-          <p:cNvSpPr/>
-          <p:nvPr/>
-        </p:nvSpPr>
-        <p:spPr>
-          <a:xfrm>
-            <a:off x="540000" y="4140000"/>
-            <a:ext cx="180000" cy="1980000"/>
-          </a:xfrm>
-          <a:prstGeom prst="rect">
-            <a:avLst/>
-          </a:prstGeom>
-          <a:solidFill>
-            <a:srgbClr val="E8B44F"/>
-          </a:solidFill>
-          <a:ln>
-            <a:noFill/>
-          </a:ln>
-          <a:effectLst/>
-        </p:spPr>
-        <p:style>
-          <a:lnRef idx="1">
-            <a:schemeClr val="accent1"/>
-          </a:lnRef>
-          <a:fillRef idx="3">
-            <a:schemeClr val="accent1"/>
-          </a:fillRef>
-          <a:effectRef idx="2">
-            <a:schemeClr val="accent1"/>
-          </a:effectRef>
-          <a:fontRef idx="minor">
-            <a:schemeClr val="lt1"/>
-          </a:fontRef>
-        </p:style>
-        <p:txBody>
-          <a:bodyPr rtlCol="0" anchor="ctr"/>
-          <a:lstStyle/>
-          <a:p>
-            <a:pPr algn="ctr"/>
-          </a:p>
-        </p:txBody>
-      </p:sp>
-      <p:sp>
-        <p:nvSpPr>
-          <p:cNvPr id="26" name="TextBox 25"/>
-          <p:cNvSpPr txBox="1"/>
-          <p:nvPr/>
-        </p:nvSpPr>
-        <p:spPr>
-          <a:xfrm>
-            <a:off x="827999" y="4356000"/>
-            <a:ext cx="10392119" cy="360000"/>
-          </a:xfrm>
-          <a:prstGeom prst="rect">
-            <a:avLst/>
-          </a:prstGeom>
-          <a:noFill/>
-        </p:spPr>
-        <p:txBody>
-          <a:bodyPr wrap="square" lIns="0" rIns="0" tIns="0" bIns="0">
-            <a:spAutoFit/>
-          </a:bodyPr>
-          <a:lstStyle/>
-          <a:p>
-            <a:pPr algn="l"/>
-            <a:r>
-              <a:rPr sz="1800" b="1" i="0">
-                <a:solidFill>
-                  <a:srgbClr val="1F4E79"/>
-                </a:solidFill>
-                <a:latin typeface="Calibri"/>
-              </a:rPr>
-              <a:t>Najbardziej prawdopodobna wycena</a:t>
-            </a:r>
-          </a:p>
-        </p:txBody>
-      </p:sp>
-      <p:sp>
-        <p:nvSpPr>
-          <p:cNvPr id="27" name="TextBox 26"/>
-          <p:cNvSpPr txBox="1"/>
-          <p:nvPr/>
-        </p:nvSpPr>
-        <p:spPr>
-          <a:xfrm>
-            <a:off x="827999" y="4788000"/>
-            <a:ext cx="10392119" cy="540000"/>
-          </a:xfrm>
-          <a:prstGeom prst="rect">
-            <a:avLst/>
-          </a:prstGeom>
-          <a:noFill/>
-        </p:spPr>
-        <p:txBody>
-          <a:bodyPr wrap="square" lIns="0" rIns="0" tIns="0" bIns="0">
-            <a:spAutoFit/>
-          </a:bodyPr>
-          <a:lstStyle/>
-          <a:p>
-            <a:pPr algn="l"/>
-            <a:r>
-              <a:rPr sz="1300" b="0" i="1">
-                <a:solidFill>
-                  <a:srgbClr val="1A1A1A"/>
-                </a:solidFill>
-                <a:latin typeface="Calibri"/>
-              </a:rPr>
-              <a:t>Polska, dojrzały produkt MVP gotowy produkcyjnie, wykonany przez polski software house:</a:t>
-            </a:r>
-          </a:p>
-        </p:txBody>
-      </p:sp>
-      <p:sp>
-        <p:nvSpPr>
-          <p:cNvPr id="28" name="TextBox 27"/>
-          <p:cNvSpPr txBox="1"/>
-          <p:nvPr/>
-        </p:nvSpPr>
-        <p:spPr>
-          <a:xfrm>
-            <a:off x="827999" y="5220000"/>
-            <a:ext cx="10392119" cy="540000"/>
-          </a:xfrm>
-          <a:prstGeom prst="rect">
-            <a:avLst/>
-          </a:prstGeom>
-          <a:noFill/>
-        </p:spPr>
-        <p:txBody>
-          <a:bodyPr wrap="square" lIns="0" rIns="0" tIns="0" bIns="0">
-            <a:spAutoFit/>
-          </a:bodyPr>
-          <a:lstStyle/>
-          <a:p>
-            <a:pPr algn="l"/>
-            <a:r>
-              <a:rPr sz="3200" b="1" i="0">
-                <a:solidFill>
-                  <a:srgbClr val="1F4E79"/>
-                </a:solidFill>
-                <a:latin typeface="Calibri"/>
-              </a:rPr>
-              <a:t>$55 000 – $75 000</a:t>
-            </a:r>
-          </a:p>
-        </p:txBody>
-      </p:sp>
-      <p:sp>
-        <p:nvSpPr>
-          <p:cNvPr id="29" name="TextBox 28"/>
-          <p:cNvSpPr txBox="1"/>
-          <p:nvPr/>
-        </p:nvSpPr>
-        <p:spPr>
-          <a:xfrm>
-            <a:off x="827999" y="5760000"/>
-            <a:ext cx="10392119" cy="288000"/>
-          </a:xfrm>
-          <a:prstGeom prst="rect">
-            <a:avLst/>
-          </a:prstGeom>
-          <a:noFill/>
-        </p:spPr>
-        <p:txBody>
-          <a:bodyPr wrap="square" lIns="0" rIns="0" tIns="0" bIns="0">
-            <a:spAutoFit/>
-          </a:bodyPr>
-          <a:lstStyle/>
-          <a:p>
-            <a:pPr algn="l"/>
-            <a:r>
-              <a:rPr sz="1300" b="0" i="1">
-                <a:solidFill>
-                  <a:srgbClr val="1A1A1A"/>
-                </a:solidFill>
-                <a:latin typeface="Calibri"/>
-              </a:rPr>
-              <a:t>Mediana wyjściowa do rozmowy z klientem: ≈ $65 000</a:t>
             </a:r>
           </a:p>
         </p:txBody>
@@ -10078,7 +7798,7 @@
                 </a:solidFill>
                 <a:latin typeface="Calibri"/>
               </a:rPr>
-              <a:t>3 / 21</a:t>
+              <a:t>3 / 19</a:t>
             </a:r>
           </a:p>
         </p:txBody>
@@ -10444,7 +8164,7 @@
                 </a:solidFill>
                 <a:latin typeface="Calibri"/>
               </a:rPr>
-              <a:t>4 / 21</a:t>
+              <a:t>4 / 19</a:t>
             </a:r>
           </a:p>
         </p:txBody>
@@ -10810,7 +8530,7 @@
                 </a:solidFill>
                 <a:latin typeface="Calibri"/>
               </a:rPr>
-              <a:t>5 / 21</a:t>
+              <a:t>5 / 19</a:t>
             </a:r>
           </a:p>
         </p:txBody>
@@ -11176,7 +8896,7 @@
                 </a:solidFill>
                 <a:latin typeface="Calibri"/>
               </a:rPr>
-              <a:t>6 / 21</a:t>
+              <a:t>6 / 19</a:t>
             </a:r>
           </a:p>
         </p:txBody>
@@ -11542,7 +9262,7 @@
                 </a:solidFill>
                 <a:latin typeface="Calibri"/>
               </a:rPr>
-              <a:t>7 / 21</a:t>
+              <a:t>7 / 19</a:t>
             </a:r>
           </a:p>
         </p:txBody>
@@ -11908,7 +9628,7 @@
                 </a:solidFill>
                 <a:latin typeface="Calibri"/>
               </a:rPr>
-              <a:t>8 / 21</a:t>
+              <a:t>8 / 19</a:t>
             </a:r>
           </a:p>
         </p:txBody>
@@ -12274,7 +9994,7 @@
                 </a:solidFill>
                 <a:latin typeface="Calibri"/>
               </a:rPr>
-              <a:t>9 / 21</a:t>
+              <a:t>9 / 19</a:t>
             </a:r>
           </a:p>
         </p:txBody>

</xml_diff>